<commit_message>
Updated the conclusions in the slides
</commit_message>
<xml_diff>
--- a/slides/ALS_Perturbation_Results.pptx
+++ b/slides/ALS_Perturbation_Results.pptx
@@ -646,8 +646,8 @@
         </p:nvSpPr>
         <p:spPr>
           <a:xfrm>
-            <a:off x="6294578" y="4643111"/>
-            <a:ext cx="258623" cy="248304"/>
+            <a:off x="6294581" y="4643112"/>
+            <a:ext cx="258621" cy="248302"/>
           </a:xfrm>
           <a:prstGeom prst="rect">
             <a:avLst/>
@@ -1466,8 +1466,8 @@
         </p:nvSpPr>
         <p:spPr>
           <a:xfrm>
-            <a:off x="164590" y="3291840"/>
-            <a:ext cx="8979412" cy="54866"/>
+            <a:off x="164589" y="3291840"/>
+            <a:ext cx="8979414" cy="54867"/>
           </a:xfrm>
           <a:prstGeom prst="rect">
             <a:avLst/>
@@ -1552,7 +1552,7 @@
         </p:nvSpPr>
         <p:spPr>
           <a:xfrm>
-            <a:off x="411479" y="1642679"/>
+            <a:off x="411479" y="1642678"/>
             <a:ext cx="8412482" cy="189360"/>
           </a:xfrm>
           <a:prstGeom prst="rect">
@@ -1601,7 +1601,7 @@
         <p:spPr>
           <a:xfrm>
             <a:off x="411479" y="2057400"/>
-            <a:ext cx="4114802" cy="0"/>
+            <a:ext cx="4114803" cy="0"/>
           </a:xfrm>
           <a:prstGeom prst="line">
             <a:avLst/>
@@ -1629,7 +1629,7 @@
         <p:spPr>
           <a:xfrm>
             <a:off x="411479" y="2377438"/>
-            <a:ext cx="1965962" cy="1097282"/>
+            <a:ext cx="1965962" cy="1097283"/>
           </a:xfrm>
           <a:prstGeom prst="rect">
             <a:avLst/>
@@ -1667,7 +1667,7 @@
         <p:spPr>
           <a:xfrm>
             <a:off x="411479" y="2377438"/>
-            <a:ext cx="1965962" cy="274322"/>
+            <a:ext cx="1965962" cy="274323"/>
           </a:xfrm>
           <a:prstGeom prst="rect">
             <a:avLst/>
@@ -1753,7 +1753,7 @@
         <p:spPr>
           <a:xfrm>
             <a:off x="457198" y="2912154"/>
-            <a:ext cx="1874523" cy="302171"/>
+            <a:ext cx="1874524" cy="302171"/>
           </a:xfrm>
           <a:prstGeom prst="rect">
             <a:avLst/>
@@ -1815,7 +1815,7 @@
         <p:spPr>
           <a:xfrm>
             <a:off x="2587750" y="2377438"/>
-            <a:ext cx="1965962" cy="1097282"/>
+            <a:ext cx="1965962" cy="1097283"/>
           </a:xfrm>
           <a:prstGeom prst="rect">
             <a:avLst/>
@@ -1853,7 +1853,7 @@
         <p:spPr>
           <a:xfrm>
             <a:off x="2587750" y="2377438"/>
-            <a:ext cx="1965962" cy="274322"/>
+            <a:ext cx="1965962" cy="274323"/>
           </a:xfrm>
           <a:prstGeom prst="rect">
             <a:avLst/>
@@ -1939,7 +1939,7 @@
         <p:spPr>
           <a:xfrm>
             <a:off x="2633471" y="2912154"/>
-            <a:ext cx="1874523" cy="302171"/>
+            <a:ext cx="1874524" cy="302171"/>
           </a:xfrm>
           <a:prstGeom prst="rect">
             <a:avLst/>
@@ -2001,7 +2001,7 @@
         <p:spPr>
           <a:xfrm>
             <a:off x="4764023" y="2377438"/>
-            <a:ext cx="1965962" cy="1097282"/>
+            <a:ext cx="1965963" cy="1097283"/>
           </a:xfrm>
           <a:prstGeom prst="rect">
             <a:avLst/>
@@ -2039,7 +2039,7 @@
         <p:spPr>
           <a:xfrm>
             <a:off x="4764023" y="2377438"/>
-            <a:ext cx="1965962" cy="274322"/>
+            <a:ext cx="1965963" cy="274323"/>
           </a:xfrm>
           <a:prstGeom prst="rect">
             <a:avLst/>
@@ -2077,7 +2077,7 @@
         <p:spPr>
           <a:xfrm>
             <a:off x="4764023" y="2451099"/>
-            <a:ext cx="1965962" cy="127001"/>
+            <a:ext cx="1965963" cy="127001"/>
           </a:xfrm>
           <a:prstGeom prst="rect">
             <a:avLst/>
@@ -2125,7 +2125,7 @@
         <p:spPr>
           <a:xfrm>
             <a:off x="4809742" y="2912154"/>
-            <a:ext cx="1874523" cy="302171"/>
+            <a:ext cx="1874524" cy="302171"/>
           </a:xfrm>
           <a:prstGeom prst="rect">
             <a:avLst/>
@@ -2187,7 +2187,7 @@
         <p:spPr>
           <a:xfrm>
             <a:off x="6940294" y="2377438"/>
-            <a:ext cx="1965962" cy="1097282"/>
+            <a:ext cx="1965963" cy="1097283"/>
           </a:xfrm>
           <a:prstGeom prst="rect">
             <a:avLst/>
@@ -2225,7 +2225,7 @@
         <p:spPr>
           <a:xfrm>
             <a:off x="6940294" y="2377438"/>
-            <a:ext cx="1965962" cy="274322"/>
+            <a:ext cx="1965963" cy="274323"/>
           </a:xfrm>
           <a:prstGeom prst="rect">
             <a:avLst/>
@@ -2263,7 +2263,7 @@
         <p:spPr>
           <a:xfrm>
             <a:off x="6940294" y="2451099"/>
-            <a:ext cx="1965962" cy="127001"/>
+            <a:ext cx="1965963" cy="127001"/>
           </a:xfrm>
           <a:prstGeom prst="rect">
             <a:avLst/>
@@ -2311,7 +2311,7 @@
         <p:spPr>
           <a:xfrm>
             <a:off x="6986016" y="2912154"/>
-            <a:ext cx="1874522" cy="302171"/>
+            <a:ext cx="1874523" cy="302171"/>
           </a:xfrm>
           <a:prstGeom prst="rect">
             <a:avLst/>
@@ -2595,7 +2595,7 @@
         <p:spPr>
           <a:xfrm>
             <a:off x="-1" y="260647"/>
-            <a:ext cx="1234442" cy="137072"/>
+            <a:ext cx="1234442" cy="137071"/>
           </a:xfrm>
           <a:prstGeom prst="rect">
             <a:avLst/>
@@ -2690,8 +2690,8 @@
         </p:nvSpPr>
         <p:spPr>
           <a:xfrm>
-            <a:off x="274319" y="804672"/>
-            <a:ext cx="4114803" cy="256033"/>
+            <a:off x="274318" y="804672"/>
+            <a:ext cx="4114805" cy="256033"/>
           </a:xfrm>
           <a:prstGeom prst="rect">
             <a:avLst/>
@@ -2776,8 +2776,8 @@
         </p:nvSpPr>
         <p:spPr>
           <a:xfrm>
-            <a:off x="274319" y="1060702"/>
-            <a:ext cx="4114803" cy="777243"/>
+            <a:off x="274318" y="1060702"/>
+            <a:ext cx="4114805" cy="777244"/>
           </a:xfrm>
           <a:prstGeom prst="rect">
             <a:avLst/>
@@ -2862,8 +2862,8 @@
         </p:nvSpPr>
         <p:spPr>
           <a:xfrm>
-            <a:off x="274319" y="1947672"/>
-            <a:ext cx="4114803" cy="256033"/>
+            <a:off x="274318" y="1947672"/>
+            <a:ext cx="4114805" cy="256033"/>
           </a:xfrm>
           <a:prstGeom prst="rect">
             <a:avLst/>
@@ -2948,8 +2948,8 @@
         </p:nvSpPr>
         <p:spPr>
           <a:xfrm>
-            <a:off x="274319" y="2221992"/>
-            <a:ext cx="4114803" cy="512066"/>
+            <a:off x="274318" y="2221992"/>
+            <a:ext cx="4114805" cy="512066"/>
           </a:xfrm>
           <a:prstGeom prst="rect">
             <a:avLst/>
@@ -3024,7 +3024,7 @@
         </p:nvSpPr>
         <p:spPr>
           <a:xfrm>
-            <a:off x="338327" y="2405379"/>
+            <a:off x="338327" y="2405378"/>
             <a:ext cx="256032" cy="127001"/>
           </a:xfrm>
           <a:prstGeom prst="rect">
@@ -3072,8 +3072,8 @@
         </p:nvSpPr>
         <p:spPr>
           <a:xfrm>
-            <a:off x="658367" y="2290615"/>
-            <a:ext cx="3657603" cy="137072"/>
+            <a:off x="658366" y="2290615"/>
+            <a:ext cx="3657605" cy="137071"/>
           </a:xfrm>
           <a:prstGeom prst="rect">
             <a:avLst/>
@@ -3120,8 +3120,8 @@
         </p:nvSpPr>
         <p:spPr>
           <a:xfrm>
-            <a:off x="658367" y="2459734"/>
-            <a:ext cx="3657603" cy="231578"/>
+            <a:off x="658366" y="2459733"/>
+            <a:ext cx="3657605" cy="231578"/>
           </a:xfrm>
           <a:prstGeom prst="rect">
             <a:avLst/>
@@ -3168,8 +3168,8 @@
         </p:nvSpPr>
         <p:spPr>
           <a:xfrm>
-            <a:off x="274319" y="2761488"/>
-            <a:ext cx="4114803" cy="512066"/>
+            <a:off x="274318" y="2761488"/>
+            <a:ext cx="4114805" cy="512066"/>
           </a:xfrm>
           <a:prstGeom prst="rect">
             <a:avLst/>
@@ -3292,8 +3292,8 @@
         </p:nvSpPr>
         <p:spPr>
           <a:xfrm>
-            <a:off x="658367" y="2830111"/>
-            <a:ext cx="3657603" cy="137072"/>
+            <a:off x="658366" y="2830110"/>
+            <a:ext cx="3657605" cy="137072"/>
           </a:xfrm>
           <a:prstGeom prst="rect">
             <a:avLst/>
@@ -3340,8 +3340,8 @@
         </p:nvSpPr>
         <p:spPr>
           <a:xfrm>
-            <a:off x="658367" y="2999232"/>
-            <a:ext cx="3657603" cy="127001"/>
+            <a:off x="658366" y="2999232"/>
+            <a:ext cx="3657605" cy="127001"/>
           </a:xfrm>
           <a:prstGeom prst="rect">
             <a:avLst/>
@@ -3388,8 +3388,8 @@
         </p:nvSpPr>
         <p:spPr>
           <a:xfrm>
-            <a:off x="274319" y="3300984"/>
-            <a:ext cx="4114803" cy="512066"/>
+            <a:off x="274318" y="3300984"/>
+            <a:ext cx="4114805" cy="512066"/>
           </a:xfrm>
           <a:prstGeom prst="rect">
             <a:avLst/>
@@ -3512,8 +3512,8 @@
         </p:nvSpPr>
         <p:spPr>
           <a:xfrm>
-            <a:off x="658367" y="3369607"/>
-            <a:ext cx="3657603" cy="137072"/>
+            <a:off x="658366" y="3369607"/>
+            <a:ext cx="3657605" cy="137071"/>
           </a:xfrm>
           <a:prstGeom prst="rect">
             <a:avLst/>
@@ -3560,8 +3560,8 @@
         </p:nvSpPr>
         <p:spPr>
           <a:xfrm>
-            <a:off x="658367" y="3538728"/>
-            <a:ext cx="3657603" cy="127001"/>
+            <a:off x="658366" y="3538728"/>
+            <a:ext cx="3657605" cy="127001"/>
           </a:xfrm>
           <a:prstGeom prst="rect">
             <a:avLst/>
@@ -3608,8 +3608,8 @@
         </p:nvSpPr>
         <p:spPr>
           <a:xfrm>
-            <a:off x="274319" y="3840479"/>
-            <a:ext cx="4114803" cy="512066"/>
+            <a:off x="274318" y="3840479"/>
+            <a:ext cx="4114805" cy="512066"/>
           </a:xfrm>
           <a:prstGeom prst="rect">
             <a:avLst/>
@@ -3732,8 +3732,8 @@
         </p:nvSpPr>
         <p:spPr>
           <a:xfrm>
-            <a:off x="658367" y="3909104"/>
-            <a:ext cx="3657603" cy="137071"/>
+            <a:off x="658366" y="3909104"/>
+            <a:ext cx="3657605" cy="137071"/>
           </a:xfrm>
           <a:prstGeom prst="rect">
             <a:avLst/>
@@ -3780,8 +3780,8 @@
         </p:nvSpPr>
         <p:spPr>
           <a:xfrm>
-            <a:off x="658367" y="4078223"/>
-            <a:ext cx="3657603" cy="127001"/>
+            <a:off x="658366" y="4078223"/>
+            <a:ext cx="3657605" cy="127001"/>
           </a:xfrm>
           <a:prstGeom prst="rect">
             <a:avLst/>
@@ -3828,8 +3828,8 @@
         </p:nvSpPr>
         <p:spPr>
           <a:xfrm>
-            <a:off x="274319" y="4379976"/>
-            <a:ext cx="4114803" cy="512066"/>
+            <a:off x="274318" y="4379976"/>
+            <a:ext cx="4114805" cy="512066"/>
           </a:xfrm>
           <a:prstGeom prst="rect">
             <a:avLst/>
@@ -3952,8 +3952,8 @@
         </p:nvSpPr>
         <p:spPr>
           <a:xfrm>
-            <a:off x="658367" y="4448600"/>
-            <a:ext cx="3657603" cy="137071"/>
+            <a:off x="658366" y="4448600"/>
+            <a:ext cx="3657605" cy="137071"/>
           </a:xfrm>
           <a:prstGeom prst="rect">
             <a:avLst/>
@@ -4000,8 +4000,8 @@
         </p:nvSpPr>
         <p:spPr>
           <a:xfrm>
-            <a:off x="658367" y="4617720"/>
-            <a:ext cx="3657603" cy="127001"/>
+            <a:off x="658366" y="4617720"/>
+            <a:ext cx="3657605" cy="127001"/>
           </a:xfrm>
           <a:prstGeom prst="rect">
             <a:avLst/>
@@ -4048,8 +4048,8 @@
         </p:nvSpPr>
         <p:spPr>
           <a:xfrm>
-            <a:off x="4663440" y="804671"/>
-            <a:ext cx="4206242" cy="4114803"/>
+            <a:off x="4663440" y="804670"/>
+            <a:ext cx="4206243" cy="4114805"/>
           </a:xfrm>
           <a:prstGeom prst="rect">
             <a:avLst/>
@@ -4104,7 +4104,7 @@
         <p:spPr>
           <a:xfrm>
             <a:off x="4709159" y="877824"/>
-            <a:ext cx="4114802" cy="3886202"/>
+            <a:ext cx="4114803" cy="3886202"/>
           </a:xfrm>
           <a:prstGeom prst="rect">
             <a:avLst/>
@@ -4232,7 +4232,7 @@
         <p:spPr>
           <a:xfrm>
             <a:off x="-1" y="260647"/>
-            <a:ext cx="1234442" cy="137072"/>
+            <a:ext cx="1234442" cy="137071"/>
           </a:xfrm>
           <a:prstGeom prst="rect">
             <a:avLst/>
@@ -4327,8 +4327,8 @@
         </p:nvSpPr>
         <p:spPr>
           <a:xfrm>
-            <a:off x="274319" y="804672"/>
-            <a:ext cx="4114803" cy="274322"/>
+            <a:off x="274318" y="804672"/>
+            <a:ext cx="4114805" cy="274322"/>
           </a:xfrm>
           <a:prstGeom prst="rect">
             <a:avLst/>
@@ -4400,7 +4400,7 @@
           <a:p>
             <a:pPr/>
             <a:r>
-              <a:t>10-GENE PANEL · 5 ALS PATHOGENIC AXES</a:t>
+              <a:t>10-GENE PANEL · 4 POPULATIONS (VAT1L + SCN4B × sALS + PN)</a:t>
             </a:r>
           </a:p>
         </p:txBody>
@@ -4414,7 +4414,7 @@
         <p:spPr>
           <a:xfrm>
             <a:off x="274320" y="1097280"/>
-            <a:ext cx="109730" cy="640082"/>
+            <a:ext cx="109731" cy="640083"/>
           </a:xfrm>
           <a:prstGeom prst="rect">
             <a:avLst/>
@@ -4452,7 +4452,7 @@
         <p:spPr>
           <a:xfrm>
             <a:off x="384047" y="1097280"/>
-            <a:ext cx="4005073" cy="640082"/>
+            <a:ext cx="4005073" cy="640083"/>
           </a:xfrm>
           <a:prstGeom prst="rect">
             <a:avLst/>
@@ -4489,8 +4489,8 @@
         </p:nvSpPr>
         <p:spPr>
           <a:xfrm>
-            <a:off x="521207" y="1189720"/>
-            <a:ext cx="3730194" cy="427420"/>
+            <a:off x="521206" y="1189721"/>
+            <a:ext cx="3730196" cy="577015"/>
           </a:xfrm>
           <a:prstGeom prst="rect">
             <a:avLst/>
@@ -4505,7 +4505,7 @@
           </a:extLst>
         </p:spPr>
         <p:txBody>
-          <a:bodyPr lIns="45719" rIns="45719">
+          <a:bodyPr lIns="45718" tIns="45718" rIns="45718" bIns="45718">
             <a:spAutoFit/>
           </a:bodyPr>
           <a:lstStyle/>
@@ -4522,7 +4522,435 @@
               </a:defRPr>
             </a:pPr>
             <a:r>
-              <a:t>TDP-43 Pathway</a:t>
+              <a:t>Pretrained model limitation: </a:t>
+            </a:r>
+            <a:r>
+              <a:rPr b="0"/>
+              <a:t>GeneFormer V2 places sALS and healthy motor neurons at cosine distance 0.003–0.006. All perturbation shifts are bounded to ~10⁻⁴. Fine-tuning on VAT1L+ &amp; SCN4B+ cells would amplify but exceeded GPU memory on g5.xlarge.</a:t>
+            </a:r>
+            <a:br>
+              <a:rPr b="0"/>
+            </a:br>
+          </a:p>
+        </p:txBody>
+      </p:sp>
+      <p:sp>
+        <p:nvSpPr>
+          <p:cNvPr id="91" name="Shape 11"/>
+          <p:cNvSpPr/>
+          <p:nvPr/>
+        </p:nvSpPr>
+        <p:spPr>
+          <a:xfrm>
+            <a:off x="274320" y="1777492"/>
+            <a:ext cx="109731" cy="640083"/>
+          </a:xfrm>
+          <a:prstGeom prst="rect">
+            <a:avLst/>
+          </a:prstGeom>
+          <a:solidFill>
+            <a:srgbClr val="E67E22"/>
+          </a:solidFill>
+          <a:ln w="12700">
+            <a:solidFill>
+              <a:srgbClr val="E67E22"/>
+            </a:solidFill>
+          </a:ln>
+        </p:spPr>
+        <p:txBody>
+          <a:bodyPr lIns="45718" tIns="45718" rIns="45718" bIns="45718"/>
+          <a:lstStyle/>
+          <a:p>
+            <a:pPr>
+              <a:defRPr>
+                <a:latin typeface="+mj-lt"/>
+                <a:ea typeface="+mj-ea"/>
+                <a:cs typeface="+mj-cs"/>
+                <a:sym typeface="Calibri"/>
+              </a:defRPr>
+            </a:pPr>
+          </a:p>
+        </p:txBody>
+      </p:sp>
+      <p:sp>
+        <p:nvSpPr>
+          <p:cNvPr id="92" name="Shape 12"/>
+          <p:cNvSpPr/>
+          <p:nvPr/>
+        </p:nvSpPr>
+        <p:spPr>
+          <a:xfrm>
+            <a:off x="384047" y="1777492"/>
+            <a:ext cx="4005073" cy="640083"/>
+          </a:xfrm>
+          <a:prstGeom prst="rect">
+            <a:avLst/>
+          </a:prstGeom>
+          <a:solidFill>
+            <a:srgbClr val="FFFFFF"/>
+          </a:solidFill>
+          <a:ln w="6350">
+            <a:solidFill>
+              <a:srgbClr val="D0DDE8"/>
+            </a:solidFill>
+          </a:ln>
+        </p:spPr>
+        <p:txBody>
+          <a:bodyPr lIns="45718" tIns="45718" rIns="45718" bIns="45718"/>
+          <a:lstStyle/>
+          <a:p>
+            <a:pPr>
+              <a:defRPr>
+                <a:latin typeface="+mj-lt"/>
+                <a:ea typeface="+mj-ea"/>
+                <a:cs typeface="+mj-cs"/>
+                <a:sym typeface="Calibri"/>
+              </a:defRPr>
+            </a:pPr>
+          </a:p>
+        </p:txBody>
+      </p:sp>
+      <p:sp>
+        <p:nvSpPr>
+          <p:cNvPr id="93" name="Text Card 2"/>
+          <p:cNvSpPr txBox="1"/>
+          <p:nvPr/>
+        </p:nvSpPr>
+        <p:spPr>
+          <a:xfrm>
+            <a:off x="521206" y="1819132"/>
+            <a:ext cx="3730196" cy="577015"/>
+          </a:xfrm>
+          <a:prstGeom prst="rect">
+            <a:avLst/>
+          </a:prstGeom>
+          <a:ln w="12700">
+            <a:miter lim="400000"/>
+          </a:ln>
+          <a:extLst>
+            <a:ext uri="{C572A759-6A51-4108-AA02-DFA0A04FC94B}">
+              <ma14:wrappingTextBoxFlag xmlns:ma14="http://schemas.microsoft.com/office/mac/drawingml/2011/main" val="1"/>
+            </a:ext>
+          </a:extLst>
+        </p:spPr>
+        <p:txBody>
+          <a:bodyPr lIns="45718" tIns="45718" rIns="45718" bIns="45718">
+            <a:spAutoFit/>
+          </a:bodyPr>
+          <a:lstStyle/>
+          <a:p>
+            <a:pPr>
+              <a:defRPr b="1" sz="800">
+                <a:solidFill>
+                  <a:srgbClr val="0A2342"/>
+                </a:solidFill>
+                <a:latin typeface="+mj-lt"/>
+                <a:ea typeface="+mj-ea"/>
+                <a:cs typeface="+mj-cs"/>
+                <a:sym typeface="Calibri"/>
+              </a:defRPr>
+            </a:pPr>
+            <a:r>
+              <a:t>Top single-gene signal: </a:t>
+            </a:r>
+            <a:r>
+              <a:rPr b="0"/>
+              <a:t>STMN2 restore - largest positive shift in disease cells. Bidirectional: healthy cells shift in opposing direction. Dose-response monotonic</a:t>
+            </a:r>
+            <a:endParaRPr b="0"/>
+          </a:p>
+          <a:p>
+            <a:pPr>
+              <a:defRPr b="1" sz="800">
+                <a:solidFill>
+                  <a:srgbClr val="0A2342"/>
+                </a:solidFill>
+                <a:latin typeface="+mj-lt"/>
+                <a:ea typeface="+mj-ea"/>
+                <a:cs typeface="+mj-cs"/>
+                <a:sym typeface="Calibri"/>
+              </a:defRPr>
+            </a:pPr>
+            <a:r>
+              <a:t>Second signal: </a:t>
+            </a:r>
+            <a:r>
+              <a:rPr b="0"/>
+              <a:t>SARM1 KD - most reproducible non-TDP-43 rescue signal (d = 0.16). Bidirectionally consistent across VAT1L populations.</a:t>
+            </a:r>
+          </a:p>
+        </p:txBody>
+      </p:sp>
+      <p:sp>
+        <p:nvSpPr>
+          <p:cNvPr id="94" name="Shape 16"/>
+          <p:cNvSpPr/>
+          <p:nvPr/>
+        </p:nvSpPr>
+        <p:spPr>
+          <a:xfrm>
+            <a:off x="274320" y="2445004"/>
+            <a:ext cx="109731" cy="640083"/>
+          </a:xfrm>
+          <a:prstGeom prst="rect">
+            <a:avLst/>
+          </a:prstGeom>
+          <a:solidFill>
+            <a:srgbClr val="C0392B"/>
+          </a:solidFill>
+          <a:ln w="12700">
+            <a:solidFill>
+              <a:srgbClr val="C0392B"/>
+            </a:solidFill>
+          </a:ln>
+        </p:spPr>
+        <p:txBody>
+          <a:bodyPr lIns="45718" tIns="45718" rIns="45718" bIns="45718"/>
+          <a:lstStyle/>
+          <a:p>
+            <a:pPr>
+              <a:defRPr>
+                <a:latin typeface="+mj-lt"/>
+                <a:ea typeface="+mj-ea"/>
+                <a:cs typeface="+mj-cs"/>
+                <a:sym typeface="Calibri"/>
+              </a:defRPr>
+            </a:pPr>
+          </a:p>
+        </p:txBody>
+      </p:sp>
+      <p:sp>
+        <p:nvSpPr>
+          <p:cNvPr id="95" name="Shape 17"/>
+          <p:cNvSpPr/>
+          <p:nvPr/>
+        </p:nvSpPr>
+        <p:spPr>
+          <a:xfrm>
+            <a:off x="384047" y="2445004"/>
+            <a:ext cx="4005073" cy="640083"/>
+          </a:xfrm>
+          <a:prstGeom prst="rect">
+            <a:avLst/>
+          </a:prstGeom>
+          <a:solidFill>
+            <a:srgbClr val="EEF4F8"/>
+          </a:solidFill>
+          <a:ln w="6350">
+            <a:solidFill>
+              <a:srgbClr val="D0DDE8"/>
+            </a:solidFill>
+          </a:ln>
+        </p:spPr>
+        <p:txBody>
+          <a:bodyPr lIns="45718" tIns="45718" rIns="45718" bIns="45718"/>
+          <a:lstStyle/>
+          <a:p>
+            <a:pPr>
+              <a:defRPr>
+                <a:latin typeface="+mj-lt"/>
+                <a:ea typeface="+mj-ea"/>
+                <a:cs typeface="+mj-cs"/>
+                <a:sym typeface="Calibri"/>
+              </a:defRPr>
+            </a:pPr>
+          </a:p>
+        </p:txBody>
+      </p:sp>
+      <p:sp>
+        <p:nvSpPr>
+          <p:cNvPr id="96" name="Text Card 3"/>
+          <p:cNvSpPr txBox="1"/>
+          <p:nvPr/>
+        </p:nvSpPr>
+        <p:spPr>
+          <a:xfrm>
+            <a:off x="521206" y="2486643"/>
+            <a:ext cx="3730196" cy="577016"/>
+          </a:xfrm>
+          <a:prstGeom prst="rect">
+            <a:avLst/>
+          </a:prstGeom>
+          <a:ln w="12700">
+            <a:miter lim="400000"/>
+          </a:ln>
+          <a:extLst>
+            <a:ext uri="{C572A759-6A51-4108-AA02-DFA0A04FC94B}">
+              <ma14:wrappingTextBoxFlag xmlns:ma14="http://schemas.microsoft.com/office/mac/drawingml/2011/main" val="1"/>
+            </a:ext>
+          </a:extLst>
+        </p:spPr>
+        <p:txBody>
+          <a:bodyPr lIns="45718" tIns="45718" rIns="45718" bIns="45718">
+            <a:spAutoFit/>
+          </a:bodyPr>
+          <a:lstStyle/>
+          <a:p>
+            <a:pPr>
+              <a:defRPr b="1" sz="800">
+                <a:solidFill>
+                  <a:srgbClr val="0A2342"/>
+                </a:solidFill>
+                <a:latin typeface="+mj-lt"/>
+                <a:ea typeface="+mj-ea"/>
+                <a:cs typeface="+mj-cs"/>
+                <a:sym typeface="Calibri"/>
+              </a:defRPr>
+            </a:pPr>
+            <a:r>
+              <a:t>Mechanism validators:</a:t>
+            </a:r>
+            <a:r>
+              <a:rPr b="0"/>
+              <a:t> </a:t>
+            </a:r>
+            <a:endParaRPr b="0"/>
+          </a:p>
+          <a:p>
+            <a:pPr defTabSz="457200">
+              <a:spcBef>
+                <a:spcPts val="1200"/>
+              </a:spcBef>
+              <a:defRPr sz="1200">
+                <a:latin typeface="Times Roman"/>
+                <a:ea typeface="Times Roman"/>
+                <a:cs typeface="Times Roman"/>
+                <a:sym typeface="Times Roman"/>
+              </a:defRPr>
+            </a:pPr>
+            <a:r>
+              <a:rPr sz="800">
+                <a:solidFill>
+                  <a:srgbClr val="0A2342"/>
+                </a:solidFill>
+                <a:latin typeface="+mj-lt"/>
+                <a:ea typeface="+mj-ea"/>
+                <a:cs typeface="+mj-cs"/>
+                <a:sym typeface="Calibri"/>
+              </a:rPr>
+              <a:t>TARDBP KD ≈ zero shift (TDP-43 is ubiquitously expressed → low rank → invisible to the model). Pathway biology detected through downstream targets (STMN2), not the hub gene.</a:t>
+            </a:r>
+          </a:p>
+        </p:txBody>
+      </p:sp>
+      <p:sp>
+        <p:nvSpPr>
+          <p:cNvPr id="97" name="Shape 21"/>
+          <p:cNvSpPr/>
+          <p:nvPr/>
+        </p:nvSpPr>
+        <p:spPr>
+          <a:xfrm>
+            <a:off x="274320" y="3137916"/>
+            <a:ext cx="109731" cy="640083"/>
+          </a:xfrm>
+          <a:prstGeom prst="rect">
+            <a:avLst/>
+          </a:prstGeom>
+          <a:solidFill>
+            <a:srgbClr val="1A73E8"/>
+          </a:solidFill>
+          <a:ln w="12700">
+            <a:solidFill>
+              <a:srgbClr val="1A73E8"/>
+            </a:solidFill>
+          </a:ln>
+        </p:spPr>
+        <p:txBody>
+          <a:bodyPr lIns="45718" tIns="45718" rIns="45718" bIns="45718"/>
+          <a:lstStyle/>
+          <a:p>
+            <a:pPr>
+              <a:defRPr>
+                <a:latin typeface="+mj-lt"/>
+                <a:ea typeface="+mj-ea"/>
+                <a:cs typeface="+mj-cs"/>
+                <a:sym typeface="Calibri"/>
+              </a:defRPr>
+            </a:pPr>
+          </a:p>
+        </p:txBody>
+      </p:sp>
+      <p:sp>
+        <p:nvSpPr>
+          <p:cNvPr id="98" name="Shape 22"/>
+          <p:cNvSpPr/>
+          <p:nvPr/>
+        </p:nvSpPr>
+        <p:spPr>
+          <a:xfrm>
+            <a:off x="384047" y="3137916"/>
+            <a:ext cx="4005073" cy="640083"/>
+          </a:xfrm>
+          <a:prstGeom prst="rect">
+            <a:avLst/>
+          </a:prstGeom>
+          <a:solidFill>
+            <a:srgbClr val="FFFFFF"/>
+          </a:solidFill>
+          <a:ln w="6350">
+            <a:solidFill>
+              <a:srgbClr val="D0DDE8"/>
+            </a:solidFill>
+          </a:ln>
+        </p:spPr>
+        <p:txBody>
+          <a:bodyPr lIns="45718" tIns="45718" rIns="45718" bIns="45718"/>
+          <a:lstStyle/>
+          <a:p>
+            <a:pPr>
+              <a:defRPr>
+                <a:latin typeface="+mj-lt"/>
+                <a:ea typeface="+mj-ea"/>
+                <a:cs typeface="+mj-cs"/>
+                <a:sym typeface="Calibri"/>
+              </a:defRPr>
+            </a:pPr>
+          </a:p>
+        </p:txBody>
+      </p:sp>
+      <p:sp>
+        <p:nvSpPr>
+          <p:cNvPr id="99" name="Text Card 4"/>
+          <p:cNvSpPr txBox="1"/>
+          <p:nvPr/>
+        </p:nvSpPr>
+        <p:spPr>
+          <a:xfrm>
+            <a:off x="521206" y="3192255"/>
+            <a:ext cx="3730196" cy="541719"/>
+          </a:xfrm>
+          <a:prstGeom prst="rect">
+            <a:avLst/>
+          </a:prstGeom>
+          <a:ln w="12700">
+            <a:miter lim="400000"/>
+          </a:ln>
+          <a:extLst>
+            <a:ext uri="{C572A759-6A51-4108-AA02-DFA0A04FC94B}">
+              <ma14:wrappingTextBoxFlag xmlns:ma14="http://schemas.microsoft.com/office/mac/drawingml/2011/main" val="1"/>
+            </a:ext>
+          </a:extLst>
+        </p:spPr>
+        <p:txBody>
+          <a:bodyPr lIns="45718" tIns="45718" rIns="45718" bIns="45718">
+            <a:spAutoFit/>
+          </a:bodyPr>
+          <a:lstStyle/>
+          <a:p>
+            <a:pPr>
+              <a:defRPr b="1" sz="800">
+                <a:solidFill>
+                  <a:srgbClr val="0A2342"/>
+                </a:solidFill>
+                <a:latin typeface="+mj-lt"/>
+                <a:ea typeface="+mj-ea"/>
+                <a:cs typeface="+mj-cs"/>
+                <a:sym typeface="Calibri"/>
+              </a:defRPr>
+            </a:pPr>
+            <a:r>
+              <a:t>Only significant combination</a:t>
             </a:r>
           </a:p>
           <a:p>
@@ -4538,31 +4966,31 @@
               </a:defRPr>
             </a:pPr>
             <a:r>
-              <a:t>TARDBP, STMN2, UNC13A, POU3F1: Central pathogenic cascade in sALS Betz cells; ~97% of sALS cases. STMN2 restoration produces largest rescue shift (+7.3e-5 cosine).</a:t>
-            </a:r>
-          </a:p>
-        </p:txBody>
-      </p:sp>
-      <p:sp>
-        <p:nvSpPr>
-          <p:cNvPr id="91" name="Shape 11"/>
+              <a:t>TDP43_full_axis (TARDBP KD + STMN2 + UNC13A restore), p = 0.012. Shift = +1.24 × 10⁻⁴, which is 2.6× the sum of individual shifts. The three genes cooperate within the TDP-43 axis — TARDBP and UNC13A contribute nothing alone but amplify the signal in combination.</a:t>
+            </a:r>
+          </a:p>
+        </p:txBody>
+      </p:sp>
+      <p:sp>
+        <p:nvSpPr>
+          <p:cNvPr id="100" name="Shape 26"/>
           <p:cNvSpPr/>
           <p:nvPr/>
         </p:nvSpPr>
         <p:spPr>
           <a:xfrm>
-            <a:off x="274320" y="1764792"/>
-            <a:ext cx="109730" cy="640082"/>
+            <a:off x="274320" y="3843528"/>
+            <a:ext cx="109731" cy="459900"/>
           </a:xfrm>
           <a:prstGeom prst="rect">
             <a:avLst/>
           </a:prstGeom>
           <a:solidFill>
-            <a:srgbClr val="E67E22"/>
+            <a:srgbClr val="0097A7"/>
           </a:solidFill>
           <a:ln w="12700">
             <a:solidFill>
-              <a:srgbClr val="E67E22"/>
+              <a:srgbClr val="0097A7"/>
             </a:solidFill>
           </a:ln>
         </p:spPr>
@@ -4583,20 +5011,20 @@
       </p:sp>
       <p:sp>
         <p:nvSpPr>
-          <p:cNvPr id="92" name="Shape 12"/>
+          <p:cNvPr id="101" name="Shape 27"/>
           <p:cNvSpPr/>
           <p:nvPr/>
         </p:nvSpPr>
         <p:spPr>
           <a:xfrm>
-            <a:off x="384047" y="1764792"/>
-            <a:ext cx="4005073" cy="640082"/>
+            <a:off x="384047" y="3843528"/>
+            <a:ext cx="4005073" cy="459900"/>
           </a:xfrm>
           <a:prstGeom prst="rect">
             <a:avLst/>
           </a:prstGeom>
           <a:solidFill>
-            <a:srgbClr val="FFFFFF"/>
+            <a:srgbClr val="EEF4F8"/>
           </a:solidFill>
           <a:ln w="6350">
             <a:solidFill>
@@ -4621,14 +5049,14 @@
       </p:sp>
       <p:sp>
         <p:nvSpPr>
-          <p:cNvPr id="93" name="Text Card 2"/>
+          <p:cNvPr id="102" name="Text Card 5"/>
           <p:cNvSpPr txBox="1"/>
           <p:nvPr/>
         </p:nvSpPr>
         <p:spPr>
           <a:xfrm>
-            <a:off x="521207" y="1857231"/>
-            <a:ext cx="3730194" cy="427421"/>
+            <a:off x="521206" y="3859768"/>
+            <a:ext cx="3730196" cy="427418"/>
           </a:xfrm>
           <a:prstGeom prst="rect">
             <a:avLst/>
@@ -4643,7 +5071,7 @@
           </a:extLst>
         </p:spPr>
         <p:txBody>
-          <a:bodyPr lIns="45719" rIns="45719">
+          <a:bodyPr lIns="45718" tIns="45718" rIns="45718" bIns="45718">
             <a:spAutoFit/>
           </a:bodyPr>
           <a:lstStyle/>
@@ -4660,7 +5088,7 @@
               </a:defRPr>
             </a:pPr>
             <a:r>
-              <a:t>Axonal Transport</a:t>
+              <a:t>ACTB control validates framework</a:t>
             </a:r>
           </a:p>
           <a:p>
@@ -4676,576 +5104,36 @@
               </a:defRPr>
             </a:pPr>
             <a:r>
-              <a:t>DCTN1, DYNC1H1: Dynein-dynactin complex. KD worsens disease state as expected, confirming pathway involvement in disease embedding geometry.</a:t>
-            </a:r>
-          </a:p>
-        </p:txBody>
-      </p:sp>
-      <p:sp>
-        <p:nvSpPr>
-          <p:cNvPr id="94" name="Shape 16"/>
-          <p:cNvSpPr/>
-          <p:nvPr/>
-        </p:nvSpPr>
-        <p:spPr>
-          <a:xfrm>
-            <a:off x="274320" y="2432304"/>
-            <a:ext cx="109730" cy="640082"/>
-          </a:xfrm>
-          <a:prstGeom prst="rect">
-            <a:avLst/>
-          </a:prstGeom>
-          <a:solidFill>
-            <a:srgbClr val="C0392B"/>
-          </a:solidFill>
-          <a:ln w="12700">
-            <a:solidFill>
-              <a:srgbClr val="C0392B"/>
-            </a:solidFill>
-          </a:ln>
-        </p:spPr>
-        <p:txBody>
-          <a:bodyPr lIns="45718" tIns="45718" rIns="45718" bIns="45718"/>
-          <a:lstStyle/>
-          <a:p>
-            <a:pPr>
-              <a:defRPr>
-                <a:latin typeface="+mj-lt"/>
-                <a:ea typeface="+mj-ea"/>
-                <a:cs typeface="+mj-cs"/>
-                <a:sym typeface="Calibri"/>
-              </a:defRPr>
-            </a:pPr>
-          </a:p>
-        </p:txBody>
-      </p:sp>
-      <p:sp>
-        <p:nvSpPr>
-          <p:cNvPr id="95" name="Shape 17"/>
-          <p:cNvSpPr/>
-          <p:nvPr/>
-        </p:nvSpPr>
-        <p:spPr>
-          <a:xfrm>
-            <a:off x="384047" y="2432304"/>
-            <a:ext cx="4005073" cy="640082"/>
-          </a:xfrm>
-          <a:prstGeom prst="rect">
-            <a:avLst/>
-          </a:prstGeom>
-          <a:solidFill>
-            <a:srgbClr val="EEF4F8"/>
-          </a:solidFill>
-          <a:ln w="6350">
-            <a:solidFill>
-              <a:srgbClr val="D0DDE8"/>
-            </a:solidFill>
-          </a:ln>
-        </p:spPr>
-        <p:txBody>
-          <a:bodyPr lIns="45718" tIns="45718" rIns="45718" bIns="45718"/>
-          <a:lstStyle/>
-          <a:p>
-            <a:pPr>
-              <a:defRPr>
-                <a:latin typeface="+mj-lt"/>
-                <a:ea typeface="+mj-ea"/>
-                <a:cs typeface="+mj-cs"/>
-                <a:sym typeface="Calibri"/>
-              </a:defRPr>
-            </a:pPr>
-          </a:p>
-        </p:txBody>
-      </p:sp>
-      <p:sp>
-        <p:nvSpPr>
-          <p:cNvPr id="96" name="Text Card 3"/>
-          <p:cNvSpPr txBox="1"/>
-          <p:nvPr/>
-        </p:nvSpPr>
-        <p:spPr>
-          <a:xfrm>
-            <a:off x="521207" y="2524743"/>
-            <a:ext cx="3730194" cy="427421"/>
-          </a:xfrm>
-          <a:prstGeom prst="rect">
-            <a:avLst/>
-          </a:prstGeom>
-          <a:ln w="12700">
-            <a:miter lim="400000"/>
-          </a:ln>
-          <a:extLst>
-            <a:ext uri="{C572A759-6A51-4108-AA02-DFA0A04FC94B}">
-              <ma14:wrappingTextBoxFlag xmlns:ma14="http://schemas.microsoft.com/office/mac/drawingml/2011/main" val="1"/>
-            </a:ext>
-          </a:extLst>
-        </p:spPr>
-        <p:txBody>
-          <a:bodyPr lIns="45719" rIns="45719">
-            <a:spAutoFit/>
-          </a:bodyPr>
-          <a:lstStyle/>
-          <a:p>
-            <a:pPr>
-              <a:defRPr b="1" sz="800">
-                <a:solidFill>
-                  <a:srgbClr val="0A2342"/>
-                </a:solidFill>
-                <a:latin typeface="+mj-lt"/>
-                <a:ea typeface="+mj-ea"/>
-                <a:cs typeface="+mj-cs"/>
-                <a:sym typeface="Calibri"/>
-              </a:defRPr>
-            </a:pPr>
-            <a:r>
-              <a:t>Axon Degeneration</a:t>
-            </a:r>
-          </a:p>
-          <a:p>
-            <a:pPr>
-              <a:defRPr sz="700">
-                <a:solidFill>
-                  <a:srgbClr val="3A4F5F"/>
-                </a:solidFill>
-                <a:latin typeface="+mj-lt"/>
-                <a:ea typeface="+mj-ea"/>
-                <a:cs typeface="+mj-cs"/>
-                <a:sym typeface="Calibri"/>
-              </a:defRPr>
-            </a:pPr>
-            <a:r>
-              <a:t>SARM1: NAD+-consuming executioner. Second-ranked non-TDP-43 gene in disease cells (d=0.16, p=0.11). Bidirectionally consistent.</a:t>
-            </a:r>
-          </a:p>
-        </p:txBody>
-      </p:sp>
-      <p:sp>
-        <p:nvSpPr>
-          <p:cNvPr id="97" name="Shape 21"/>
-          <p:cNvSpPr/>
-          <p:nvPr/>
-        </p:nvSpPr>
-        <p:spPr>
-          <a:xfrm>
-            <a:off x="274320" y="3099816"/>
-            <a:ext cx="109730" cy="640082"/>
-          </a:xfrm>
-          <a:prstGeom prst="rect">
-            <a:avLst/>
-          </a:prstGeom>
-          <a:solidFill>
-            <a:srgbClr val="1A73E8"/>
-          </a:solidFill>
-          <a:ln w="12700">
-            <a:solidFill>
-              <a:srgbClr val="1A73E8"/>
-            </a:solidFill>
-          </a:ln>
-        </p:spPr>
-        <p:txBody>
-          <a:bodyPr lIns="45718" tIns="45718" rIns="45718" bIns="45718"/>
-          <a:lstStyle/>
-          <a:p>
-            <a:pPr>
-              <a:defRPr>
-                <a:latin typeface="+mj-lt"/>
-                <a:ea typeface="+mj-ea"/>
-                <a:cs typeface="+mj-cs"/>
-                <a:sym typeface="Calibri"/>
-              </a:defRPr>
-            </a:pPr>
-          </a:p>
-        </p:txBody>
-      </p:sp>
-      <p:sp>
-        <p:nvSpPr>
-          <p:cNvPr id="98" name="Shape 22"/>
-          <p:cNvSpPr/>
-          <p:nvPr/>
-        </p:nvSpPr>
-        <p:spPr>
-          <a:xfrm>
-            <a:off x="384047" y="3099816"/>
-            <a:ext cx="4005073" cy="640082"/>
-          </a:xfrm>
-          <a:prstGeom prst="rect">
-            <a:avLst/>
-          </a:prstGeom>
-          <a:solidFill>
-            <a:srgbClr val="FFFFFF"/>
-          </a:solidFill>
-          <a:ln w="6350">
-            <a:solidFill>
-              <a:srgbClr val="D0DDE8"/>
-            </a:solidFill>
-          </a:ln>
-        </p:spPr>
-        <p:txBody>
-          <a:bodyPr lIns="45718" tIns="45718" rIns="45718" bIns="45718"/>
-          <a:lstStyle/>
-          <a:p>
-            <a:pPr>
-              <a:defRPr>
-                <a:latin typeface="+mj-lt"/>
-                <a:ea typeface="+mj-ea"/>
-                <a:cs typeface="+mj-cs"/>
-                <a:sym typeface="Calibri"/>
-              </a:defRPr>
-            </a:pPr>
-          </a:p>
-        </p:txBody>
-      </p:sp>
-      <p:sp>
-        <p:nvSpPr>
-          <p:cNvPr id="99" name="Text Card 4"/>
-          <p:cNvSpPr txBox="1"/>
-          <p:nvPr/>
-        </p:nvSpPr>
-        <p:spPr>
-          <a:xfrm>
-            <a:off x="521207" y="3192255"/>
-            <a:ext cx="3730194" cy="427421"/>
-          </a:xfrm>
-          <a:prstGeom prst="rect">
-            <a:avLst/>
-          </a:prstGeom>
-          <a:ln w="12700">
-            <a:miter lim="400000"/>
-          </a:ln>
-          <a:extLst>
-            <a:ext uri="{C572A759-6A51-4108-AA02-DFA0A04FC94B}">
-              <ma14:wrappingTextBoxFlag xmlns:ma14="http://schemas.microsoft.com/office/mac/drawingml/2011/main" val="1"/>
-            </a:ext>
-          </a:extLst>
-        </p:spPr>
-        <p:txBody>
-          <a:bodyPr lIns="45719" rIns="45719">
-            <a:spAutoFit/>
-          </a:bodyPr>
-          <a:lstStyle/>
-          <a:p>
-            <a:pPr>
-              <a:defRPr b="1" sz="800">
-                <a:solidFill>
-                  <a:srgbClr val="0A2342"/>
-                </a:solidFill>
-                <a:latin typeface="+mj-lt"/>
-                <a:ea typeface="+mj-ea"/>
-                <a:cs typeface="+mj-cs"/>
-                <a:sym typeface="Calibri"/>
-              </a:defRPr>
-            </a:pPr>
-            <a:r>
-              <a:t>DNA Repair / NCT</a:t>
-            </a:r>
-          </a:p>
-          <a:p>
-            <a:pPr>
-              <a:defRPr sz="700">
-                <a:solidFill>
-                  <a:srgbClr val="3A4F5F"/>
-                </a:solidFill>
-                <a:latin typeface="+mj-lt"/>
-                <a:ea typeface="+mj-ea"/>
-                <a:cs typeface="+mj-cs"/>
-                <a:sym typeface="Calibri"/>
-              </a:defRPr>
-            </a:pPr>
-            <a:r>
-              <a:t>NEK1: GWAS + rare burden gene. KD produces disease-exacerbating shift, consistent with loss of DNA repair function in motor neurons.</a:t>
-            </a:r>
-          </a:p>
-        </p:txBody>
-      </p:sp>
-      <p:sp>
-        <p:nvSpPr>
-          <p:cNvPr id="100" name="Shape 26"/>
-          <p:cNvSpPr/>
-          <p:nvPr/>
-        </p:nvSpPr>
-        <p:spPr>
-          <a:xfrm>
-            <a:off x="274320" y="3767328"/>
-            <a:ext cx="109730" cy="584161"/>
-          </a:xfrm>
-          <a:prstGeom prst="rect">
-            <a:avLst/>
-          </a:prstGeom>
-          <a:solidFill>
-            <a:srgbClr val="0097A7"/>
-          </a:solidFill>
-          <a:ln w="12700">
-            <a:solidFill>
-              <a:srgbClr val="0097A7"/>
-            </a:solidFill>
-          </a:ln>
-        </p:spPr>
-        <p:txBody>
-          <a:bodyPr lIns="45718" tIns="45718" rIns="45718" bIns="45718"/>
-          <a:lstStyle/>
-          <a:p>
-            <a:pPr>
-              <a:defRPr>
-                <a:latin typeface="+mj-lt"/>
-                <a:ea typeface="+mj-ea"/>
-                <a:cs typeface="+mj-cs"/>
-                <a:sym typeface="Calibri"/>
-              </a:defRPr>
-            </a:pPr>
-          </a:p>
-        </p:txBody>
-      </p:sp>
-      <p:sp>
-        <p:nvSpPr>
-          <p:cNvPr id="101" name="Shape 27"/>
-          <p:cNvSpPr/>
-          <p:nvPr/>
-        </p:nvSpPr>
-        <p:spPr>
-          <a:xfrm>
-            <a:off x="384047" y="3767328"/>
-            <a:ext cx="4005073" cy="575231"/>
-          </a:xfrm>
-          <a:prstGeom prst="rect">
-            <a:avLst/>
-          </a:prstGeom>
-          <a:solidFill>
-            <a:srgbClr val="EEF4F8"/>
-          </a:solidFill>
-          <a:ln w="6350">
-            <a:solidFill>
-              <a:srgbClr val="D0DDE8"/>
-            </a:solidFill>
-          </a:ln>
-        </p:spPr>
-        <p:txBody>
-          <a:bodyPr lIns="45718" tIns="45718" rIns="45718" bIns="45718"/>
-          <a:lstStyle/>
-          <a:p>
-            <a:pPr>
-              <a:defRPr>
-                <a:latin typeface="+mj-lt"/>
-                <a:ea typeface="+mj-ea"/>
-                <a:cs typeface="+mj-cs"/>
-                <a:sym typeface="Calibri"/>
-              </a:defRPr>
-            </a:pPr>
-          </a:p>
-        </p:txBody>
-      </p:sp>
-      <p:sp>
-        <p:nvSpPr>
-          <p:cNvPr id="102" name="Text Card 5"/>
-          <p:cNvSpPr txBox="1"/>
-          <p:nvPr/>
-        </p:nvSpPr>
-        <p:spPr>
-          <a:xfrm>
-            <a:off x="521207" y="3859767"/>
-            <a:ext cx="3730194" cy="427421"/>
-          </a:xfrm>
-          <a:prstGeom prst="rect">
-            <a:avLst/>
-          </a:prstGeom>
-          <a:ln w="12700">
-            <a:miter lim="400000"/>
-          </a:ln>
-          <a:extLst>
-            <a:ext uri="{C572A759-6A51-4108-AA02-DFA0A04FC94B}">
-              <ma14:wrappingTextBoxFlag xmlns:ma14="http://schemas.microsoft.com/office/mac/drawingml/2011/main" val="1"/>
-            </a:ext>
-          </a:extLst>
-        </p:spPr>
-        <p:txBody>
-          <a:bodyPr lIns="45719" rIns="45719">
-            <a:spAutoFit/>
-          </a:bodyPr>
-          <a:lstStyle/>
-          <a:p>
-            <a:pPr>
-              <a:defRPr b="1" sz="800">
-                <a:solidFill>
-                  <a:srgbClr val="0A2342"/>
-                </a:solidFill>
-                <a:latin typeface="+mj-lt"/>
-                <a:ea typeface="+mj-ea"/>
-                <a:cs typeface="+mj-cs"/>
-                <a:sym typeface="Calibri"/>
-              </a:defRPr>
-            </a:pPr>
-            <a:r>
-              <a:t>Selective Autophagy</a:t>
-            </a:r>
-          </a:p>
-          <a:p>
-            <a:pPr>
-              <a:defRPr sz="700">
-                <a:solidFill>
-                  <a:srgbClr val="3A4F5F"/>
-                </a:solidFill>
-                <a:latin typeface="+mj-lt"/>
-                <a:ea typeface="+mj-ea"/>
-                <a:cs typeface="+mj-cs"/>
-                <a:sym typeface="Calibri"/>
-              </a:defRPr>
-            </a:pPr>
-            <a:r>
-              <a:t>TBK1, OPTN: Loss-of-function in ALS. TBK1 phosphorylates OPTN for TDP-43 aggregate clearance. Both bidirectionally consistent.</a:t>
-            </a:r>
-          </a:p>
-        </p:txBody>
-      </p:sp>
-      <p:sp>
-        <p:nvSpPr>
-          <p:cNvPr id="103" name="Shape 31"/>
-          <p:cNvSpPr/>
-          <p:nvPr/>
-        </p:nvSpPr>
-        <p:spPr>
-          <a:xfrm>
-            <a:off x="274319" y="4384040"/>
-            <a:ext cx="4114803" cy="584161"/>
-          </a:xfrm>
-          <a:prstGeom prst="rect">
-            <a:avLst/>
-          </a:prstGeom>
-          <a:solidFill>
-            <a:srgbClr val="E8F5E9"/>
-          </a:solidFill>
-          <a:ln w="12700">
-            <a:solidFill>
-              <a:srgbClr val="388E3C"/>
-            </a:solidFill>
-          </a:ln>
-        </p:spPr>
-        <p:txBody>
-          <a:bodyPr lIns="45718" tIns="45718" rIns="45718" bIns="45718"/>
-          <a:lstStyle/>
-          <a:p>
-            <a:pPr>
-              <a:defRPr>
-                <a:latin typeface="+mj-lt"/>
-                <a:ea typeface="+mj-ea"/>
-                <a:cs typeface="+mj-cs"/>
-                <a:sym typeface="Calibri"/>
-              </a:defRPr>
-            </a:pPr>
-          </a:p>
-        </p:txBody>
-      </p:sp>
-      <p:sp>
-        <p:nvSpPr>
-          <p:cNvPr id="104" name="Text 32"/>
-          <p:cNvSpPr txBox="1"/>
-          <p:nvPr/>
-        </p:nvSpPr>
-        <p:spPr>
-          <a:xfrm>
-            <a:off x="347470" y="4439410"/>
-            <a:ext cx="3968500" cy="127001"/>
-          </a:xfrm>
-          <a:prstGeom prst="rect">
-            <a:avLst/>
-          </a:prstGeom>
-          <a:ln w="12700">
-            <a:miter lim="400000"/>
-          </a:ln>
-          <a:extLst>
-            <a:ext uri="{C572A759-6A51-4108-AA02-DFA0A04FC94B}">
-              <ma14:wrappingTextBoxFlag xmlns:ma14="http://schemas.microsoft.com/office/mac/drawingml/2011/main" val="1"/>
-            </a:ext>
-          </a:extLst>
-        </p:spPr>
-        <p:txBody>
-          <a:bodyPr lIns="0" tIns="0" rIns="0" bIns="0" anchor="ctr">
-            <a:spAutoFit/>
-          </a:bodyPr>
-          <a:lstStyle>
-            <a:lvl1pPr>
-              <a:defRPr b="1" sz="800">
-                <a:solidFill>
-                  <a:srgbClr val="1B5E20"/>
-                </a:solidFill>
-                <a:latin typeface="+mj-lt"/>
-                <a:ea typeface="+mj-ea"/>
-                <a:cs typeface="+mj-cs"/>
-                <a:sym typeface="Calibri"/>
-              </a:defRPr>
-            </a:lvl1pPr>
-          </a:lstStyle>
-          <a:p>
-            <a:pPr/>
-            <a:r>
-              <a:t>KEY FINDING</a:t>
-            </a:r>
-          </a:p>
-        </p:txBody>
-      </p:sp>
-      <p:sp>
-        <p:nvSpPr>
-          <p:cNvPr id="105" name="Text Key Finding"/>
-          <p:cNvSpPr txBox="1"/>
-          <p:nvPr/>
-        </p:nvSpPr>
-        <p:spPr>
-          <a:xfrm>
-            <a:off x="393190" y="4539200"/>
-            <a:ext cx="3968498" cy="414720"/>
-          </a:xfrm>
-          <a:prstGeom prst="rect">
-            <a:avLst/>
-          </a:prstGeom>
-          <a:ln w="12700">
-            <a:miter lim="400000"/>
-          </a:ln>
-          <a:extLst>
-            <a:ext uri="{C572A759-6A51-4108-AA02-DFA0A04FC94B}">
-              <ma14:wrappingTextBoxFlag xmlns:ma14="http://schemas.microsoft.com/office/mac/drawingml/2011/main" val="1"/>
-            </a:ext>
-          </a:extLst>
-        </p:spPr>
-        <p:txBody>
-          <a:bodyPr lIns="45719" rIns="45719">
-            <a:spAutoFit/>
-          </a:bodyPr>
-          <a:lstStyle>
-            <a:lvl1pPr>
-              <a:defRPr sz="700">
-                <a:solidFill>
-                  <a:srgbClr val="1B5E20"/>
-                </a:solidFill>
-                <a:latin typeface="+mj-lt"/>
-                <a:ea typeface="+mj-ea"/>
-                <a:cs typeface="+mj-cs"/>
-                <a:sym typeface="Calibri"/>
-              </a:defRPr>
-            </a:lvl1pPr>
-          </a:lstStyle>
-          <a:p>
-            <a:pPr/>
-            <a:r>
-              <a:t>STMN2 is the #1 single-gene signal. TDP43_full_axis combination (TARDBP KD + STMN2 + UNC13A restore) is the only statistically significant combination (p=0.012, 2.6x synergy over individual shifts). 0/44 single-gene perturbations reached FDR &lt; 0.05 — fine-tuning is required.</a:t>
-            </a:r>
-          </a:p>
-        </p:txBody>
-      </p:sp>
-      <p:sp>
-        <p:nvSpPr>
-          <p:cNvPr id="106" name="Shape 34"/>
-          <p:cNvSpPr/>
-          <p:nvPr/>
-        </p:nvSpPr>
-        <p:spPr>
-          <a:xfrm>
-            <a:off x="4663440" y="804671"/>
-            <a:ext cx="4206242" cy="4114803"/>
-          </a:xfrm>
-          <a:prstGeom prst="rect">
-            <a:avLst/>
-          </a:prstGeom>
-          <a:solidFill>
-            <a:srgbClr val="FFFFFF"/>
-          </a:solidFill>
+              <a:t>near-zero shift in disease cells despite being the most differentially expressed gene in the panel (log2FC = −1.04).</a:t>
+            </a:r>
+          </a:p>
+        </p:txBody>
+      </p:sp>
+      <p:pic>
+        <p:nvPicPr>
+          <p:cNvPr id="103" name="task2_summary.png" descr="task2_summary.png"/>
+          <p:cNvPicPr>
+            <a:picLocks noChangeAspect="1"/>
+          </p:cNvPicPr>
+          <p:nvPr/>
+        </p:nvPicPr>
+        <p:blipFill>
+          <a:blip r:embed="rId2">
+            <a:extLst/>
+          </a:blip>
+          <a:srcRect l="537" t="0" r="0" b="0"/>
+          <a:stretch>
+            <a:fillRect/>
+          </a:stretch>
+        </p:blipFill>
+        <p:spPr>
+          <a:xfrm>
+            <a:off x="4663440" y="832953"/>
+            <a:ext cx="4095515" cy="3025739"/>
+          </a:xfrm>
+          <a:prstGeom prst="rect">
+            <a:avLst/>
+          </a:prstGeom>
           <a:ln w="12700">
             <a:solidFill>
               <a:srgbClr val="D0DDE8"/>
@@ -5259,6 +5147,32 @@
             </a:outerShdw>
           </a:effectLst>
         </p:spPr>
+      </p:pic>
+      <p:sp>
+        <p:nvSpPr>
+          <p:cNvPr id="104" name="Shape 26"/>
+          <p:cNvSpPr/>
+          <p:nvPr/>
+        </p:nvSpPr>
+        <p:spPr>
+          <a:xfrm>
+            <a:off x="275908" y="4356053"/>
+            <a:ext cx="109731" cy="316666"/>
+          </a:xfrm>
+          <a:prstGeom prst="rect">
+            <a:avLst/>
+          </a:prstGeom>
+          <a:solidFill>
+            <a:srgbClr val="14A51B"/>
+          </a:solidFill>
+          <a:ln w="12700">
+            <a:solidFill>
+              <a:schemeClr val="accent6">
+                <a:lumOff val="-9568"/>
+              </a:schemeClr>
+            </a:solidFill>
+          </a:ln>
+        </p:spPr>
         <p:txBody>
           <a:bodyPr lIns="45718" tIns="45718" rIns="45718" bIns="45718"/>
           <a:lstStyle/>
@@ -5274,26 +5188,54 @@
           </a:p>
         </p:txBody>
       </p:sp>
-      <p:pic>
-        <p:nvPicPr>
-          <p:cNvPr id="107" name="Image 0" descr="Image 0"/>
-          <p:cNvPicPr>
-            <a:picLocks noChangeAspect="1"/>
-          </p:cNvPicPr>
-          <p:nvPr/>
-        </p:nvPicPr>
-        <p:blipFill>
-          <a:blip r:embed="rId2">
-            <a:extLst/>
-          </a:blip>
-          <a:stretch>
-            <a:fillRect/>
-          </a:stretch>
-        </p:blipFill>
-        <p:spPr>
-          <a:xfrm>
-            <a:off x="4709159" y="877824"/>
-            <a:ext cx="4114802" cy="3886202"/>
+      <p:sp>
+        <p:nvSpPr>
+          <p:cNvPr id="105" name="Shape 27"/>
+          <p:cNvSpPr/>
+          <p:nvPr/>
+        </p:nvSpPr>
+        <p:spPr>
+          <a:xfrm>
+            <a:off x="385635" y="4356053"/>
+            <a:ext cx="4005073" cy="316666"/>
+          </a:xfrm>
+          <a:prstGeom prst="rect">
+            <a:avLst/>
+          </a:prstGeom>
+          <a:solidFill>
+            <a:srgbClr val="EEF4F8"/>
+          </a:solidFill>
+          <a:ln w="6350">
+            <a:solidFill>
+              <a:srgbClr val="D0DDE8"/>
+            </a:solidFill>
+          </a:ln>
+        </p:spPr>
+        <p:txBody>
+          <a:bodyPr lIns="45718" tIns="45718" rIns="45718" bIns="45718"/>
+          <a:lstStyle/>
+          <a:p>
+            <a:pPr>
+              <a:defRPr>
+                <a:latin typeface="+mj-lt"/>
+                <a:ea typeface="+mj-ea"/>
+                <a:cs typeface="+mj-cs"/>
+                <a:sym typeface="Calibri"/>
+              </a:defRPr>
+            </a:pPr>
+          </a:p>
+        </p:txBody>
+      </p:sp>
+      <p:sp>
+        <p:nvSpPr>
+          <p:cNvPr id="106" name="Text Card 5"/>
+          <p:cNvSpPr txBox="1"/>
+          <p:nvPr/>
+        </p:nvSpPr>
+        <p:spPr>
+          <a:xfrm>
+            <a:off x="522795" y="4372294"/>
+            <a:ext cx="3730195" cy="323015"/>
           </a:xfrm>
           <a:prstGeom prst="rect">
             <a:avLst/>
@@ -5301,8 +5243,37 @@
           <a:ln w="12700">
             <a:miter lim="400000"/>
           </a:ln>
-        </p:spPr>
-      </p:pic>
+          <a:extLst>
+            <a:ext uri="{C572A759-6A51-4108-AA02-DFA0A04FC94B}">
+              <ma14:wrappingTextBoxFlag xmlns:ma14="http://schemas.microsoft.com/office/mac/drawingml/2011/main" val="1"/>
+            </a:ext>
+          </a:extLst>
+        </p:spPr>
+        <p:txBody>
+          <a:bodyPr lIns="45718" tIns="45718" rIns="45718" bIns="45718">
+            <a:spAutoFit/>
+          </a:bodyPr>
+          <a:lstStyle>
+            <a:lvl1pPr>
+              <a:defRPr b="1" sz="800">
+                <a:solidFill>
+                  <a:srgbClr val="0A2342"/>
+                </a:solidFill>
+                <a:latin typeface="+mj-lt"/>
+                <a:ea typeface="+mj-ea"/>
+                <a:cs typeface="+mj-cs"/>
+                <a:sym typeface="Calibri"/>
+              </a:defRPr>
+            </a:lvl1pPr>
+          </a:lstStyle>
+          <a:p>
+            <a:pPr/>
+            <a:r>
+              <a:t>0/44 individual perturbations FDR &lt; 0.05: fine-tuning is required for per-gene significance.</a:t>
+            </a:r>
+          </a:p>
+        </p:txBody>
+      </p:sp>
     </p:spTree>
   </p:cSld>
   <p:clrMapOvr>
@@ -5338,7 +5309,93 @@
       </p:grpSpPr>
       <p:sp>
         <p:nvSpPr>
-          <p:cNvPr id="109" name="Shape 0"/>
+          <p:cNvPr id="108" name="Shape 26"/>
+          <p:cNvSpPr/>
+          <p:nvPr/>
+        </p:nvSpPr>
+        <p:spPr>
+          <a:xfrm>
+            <a:off x="4636770" y="4450125"/>
+            <a:ext cx="4013204" cy="583321"/>
+          </a:xfrm>
+          <a:prstGeom prst="rect">
+            <a:avLst/>
+          </a:prstGeom>
+          <a:gradFill>
+            <a:gsLst>
+              <a:gs pos="0">
+                <a:schemeClr val="accent4">
+                  <a:hueOff val="-617933"/>
+                  <a:lumOff val="36487"/>
+                </a:schemeClr>
+              </a:gs>
+              <a:gs pos="35000">
+                <a:srgbClr val="FFEACF"/>
+              </a:gs>
+              <a:gs pos="100000">
+                <a:schemeClr val="accent4">
+                  <a:hueOff val="-742744"/>
+                  <a:lumOff val="46439"/>
+                </a:schemeClr>
+              </a:gs>
+            </a:gsLst>
+            <a:lin ang="16200000"/>
+          </a:gradFill>
+          <a:ln>
+            <a:solidFill>
+              <a:srgbClr val="F9BC00"/>
+            </a:solidFill>
+          </a:ln>
+        </p:spPr>
+        <p:txBody>
+          <a:bodyPr lIns="45718" tIns="45718" rIns="45718" bIns="45718"/>
+          <a:lstStyle/>
+          <a:p>
+            <a:pPr/>
+          </a:p>
+        </p:txBody>
+      </p:sp>
+      <p:sp>
+        <p:nvSpPr>
+          <p:cNvPr id="109" name="Shape 26"/>
+          <p:cNvSpPr/>
+          <p:nvPr/>
+        </p:nvSpPr>
+        <p:spPr>
+          <a:xfrm>
+            <a:off x="274318" y="2817595"/>
+            <a:ext cx="4114805" cy="687611"/>
+          </a:xfrm>
+          <a:prstGeom prst="rect">
+            <a:avLst/>
+          </a:prstGeom>
+          <a:solidFill>
+            <a:srgbClr val="EEF4F8"/>
+          </a:solidFill>
+          <a:ln w="6350">
+            <a:solidFill>
+              <a:srgbClr val="D0DDE8"/>
+            </a:solidFill>
+          </a:ln>
+        </p:spPr>
+        <p:txBody>
+          <a:bodyPr lIns="45718" tIns="45718" rIns="45718" bIns="45718"/>
+          <a:lstStyle/>
+          <a:p>
+            <a:pPr>
+              <a:defRPr>
+                <a:latin typeface="+mj-lt"/>
+                <a:ea typeface="+mj-ea"/>
+                <a:cs typeface="+mj-cs"/>
+                <a:sym typeface="Calibri"/>
+              </a:defRPr>
+            </a:pPr>
+          </a:p>
+        </p:txBody>
+      </p:sp>
+      <p:sp>
+        <p:nvSpPr>
+          <p:cNvPr id="110" name="Shape 0"/>
           <p:cNvSpPr/>
           <p:nvPr/>
         </p:nvSpPr>
@@ -5376,7 +5433,7 @@
       </p:sp>
       <p:sp>
         <p:nvSpPr>
-          <p:cNvPr id="110" name="Shape 1"/>
+          <p:cNvPr id="111" name="Shape 1"/>
           <p:cNvSpPr/>
           <p:nvPr/>
         </p:nvSpPr>
@@ -5414,14 +5471,14 @@
       </p:sp>
       <p:sp>
         <p:nvSpPr>
-          <p:cNvPr id="111" name="Text 2"/>
+          <p:cNvPr id="112" name="Text 2"/>
           <p:cNvSpPr txBox="1"/>
           <p:nvPr/>
         </p:nvSpPr>
         <p:spPr>
           <a:xfrm>
             <a:off x="-1" y="260647"/>
-            <a:ext cx="1234442" cy="137072"/>
+            <a:ext cx="1234442" cy="137071"/>
           </a:xfrm>
           <a:prstGeom prst="rect">
             <a:avLst/>
@@ -5462,7 +5519,7 @@
       </p:sp>
       <p:sp>
         <p:nvSpPr>
-          <p:cNvPr id="112" name="Text 3"/>
+          <p:cNvPr id="113" name="Text 3"/>
           <p:cNvSpPr txBox="1"/>
           <p:nvPr/>
         </p:nvSpPr>
@@ -5510,14 +5567,14 @@
       </p:sp>
       <p:sp>
         <p:nvSpPr>
-          <p:cNvPr id="113" name="Shape 4"/>
+          <p:cNvPr id="114" name="Shape 4"/>
           <p:cNvSpPr/>
           <p:nvPr/>
         </p:nvSpPr>
         <p:spPr>
           <a:xfrm>
-            <a:off x="274319" y="804672"/>
-            <a:ext cx="4114803" cy="256033"/>
+            <a:off x="274318" y="804672"/>
+            <a:ext cx="4114805" cy="256033"/>
           </a:xfrm>
           <a:prstGeom prst="rect">
             <a:avLst/>
@@ -5548,7 +5605,7 @@
       </p:sp>
       <p:sp>
         <p:nvSpPr>
-          <p:cNvPr id="114" name="Text 5"/>
+          <p:cNvPr id="115" name="Text 5"/>
           <p:cNvSpPr txBox="1"/>
           <p:nvPr/>
         </p:nvSpPr>
@@ -5589,21 +5646,21 @@
           <a:p>
             <a:pPr/>
             <a:r>
-              <a:t>5 ANALYTICAL LENSES</a:t>
-            </a:r>
-          </a:p>
-        </p:txBody>
-      </p:sp>
-      <p:sp>
-        <p:nvSpPr>
-          <p:cNvPr id="115" name="Shape 6"/>
+              <a:t>5 ANALYTICAL LENSES ON PERTURBATION EFFECTS (VAT1L + SCN4B sALS)</a:t>
+            </a:r>
+          </a:p>
+        </p:txBody>
+      </p:sp>
+      <p:sp>
+        <p:nvSpPr>
+          <p:cNvPr id="116" name="Shape 6"/>
           <p:cNvSpPr/>
           <p:nvPr/>
         </p:nvSpPr>
         <p:spPr>
           <a:xfrm>
-            <a:off x="274319" y="1078991"/>
-            <a:ext cx="4114803" cy="731523"/>
+            <a:off x="274318" y="1104391"/>
+            <a:ext cx="4114805" cy="664720"/>
           </a:xfrm>
           <a:prstGeom prst="rect">
             <a:avLst/>
@@ -5634,14 +5691,14 @@
       </p:sp>
       <p:sp>
         <p:nvSpPr>
-          <p:cNvPr id="116" name="Shape 7"/>
+          <p:cNvPr id="117" name="Shape 7"/>
           <p:cNvSpPr/>
           <p:nvPr/>
         </p:nvSpPr>
         <p:spPr>
           <a:xfrm>
-            <a:off x="347472" y="1298446"/>
-            <a:ext cx="274323" cy="274324"/>
+            <a:off x="347472" y="1323846"/>
+            <a:ext cx="274325" cy="274325"/>
           </a:xfrm>
           <a:prstGeom prst="ellipse">
             <a:avLst/>
@@ -5672,14 +5729,14 @@
       </p:sp>
       <p:sp>
         <p:nvSpPr>
-          <p:cNvPr id="117" name="Text 8"/>
+          <p:cNvPr id="118" name="Text 8"/>
           <p:cNvSpPr txBox="1"/>
           <p:nvPr/>
         </p:nvSpPr>
         <p:spPr>
           <a:xfrm>
-            <a:off x="347472" y="1367071"/>
-            <a:ext cx="274322" cy="137072"/>
+            <a:off x="347472" y="1392471"/>
+            <a:ext cx="274322" cy="137071"/>
           </a:xfrm>
           <a:prstGeom prst="rect">
             <a:avLst/>
@@ -5720,13 +5777,13 @@
       </p:sp>
       <p:sp>
         <p:nvSpPr>
-          <p:cNvPr id="118" name="Text 9"/>
+          <p:cNvPr id="119" name="Text 9"/>
           <p:cNvSpPr txBox="1"/>
           <p:nvPr/>
         </p:nvSpPr>
         <p:spPr>
           <a:xfrm>
-            <a:off x="694944" y="1180083"/>
+            <a:off x="694944" y="1205483"/>
             <a:ext cx="3621024" cy="127001"/>
           </a:xfrm>
           <a:prstGeom prst="rect">
@@ -5761,21 +5818,21 @@
           <a:p>
             <a:pPr/>
             <a:r>
-              <a:t>A: Multi-Metric Comparison</a:t>
-            </a:r>
-          </a:p>
-        </p:txBody>
-      </p:sp>
-      <p:sp>
-        <p:nvSpPr>
-          <p:cNvPr id="119" name="Text Description 1"/>
+              <a:t>1 UMAP + Per-Gene Trajectories</a:t>
+            </a:r>
+          </a:p>
+        </p:txBody>
+      </p:sp>
+      <p:sp>
+        <p:nvSpPr>
+          <p:cNvPr id="120" name="Text Description 1"/>
           <p:cNvSpPr txBox="1"/>
           <p:nvPr/>
         </p:nvSpPr>
         <p:spPr>
           <a:xfrm>
-            <a:off x="694944" y="1320082"/>
-            <a:ext cx="3621024" cy="358578"/>
+            <a:off x="694944" y="1345482"/>
+            <a:ext cx="3621024" cy="358577"/>
           </a:xfrm>
           <a:prstGeom prst="rect">
             <a:avLst/>
@@ -5793,9 +5850,8 @@
           <a:bodyPr lIns="0" tIns="0" rIns="0" bIns="0">
             <a:spAutoFit/>
           </a:bodyPr>
-          <a:lstStyle/>
-          <a:p>
-            <a:pPr>
+          <a:lstStyle>
+            <a:lvl1pPr>
               <a:defRPr sz="800">
                 <a:solidFill>
                   <a:srgbClr val="4A6070"/>
@@ -5805,39 +5861,26 @@
                 <a:cs typeface="+mj-cs"/>
                 <a:sym typeface="Calibri"/>
               </a:defRPr>
-            </a:pPr>
-            <a:r>
-              <a:t>STMN2 is a clear outlier: highest cosine shift (~2.1) and on-axis shift (~2.7) simultaneously</a:t>
-            </a:r>
-          </a:p>
-          <a:p>
-            <a:pPr>
-              <a:defRPr sz="800">
-                <a:solidFill>
-                  <a:srgbClr val="4A6070"/>
-                </a:solidFill>
-                <a:latin typeface="+mj-lt"/>
-                <a:ea typeface="+mj-ea"/>
-                <a:cs typeface="+mj-cs"/>
-                <a:sym typeface="Calibri"/>
-              </a:defRPr>
-            </a:pPr>
-            <a:r>
-              <a:t>TARDBP scores high on dHNF but near-zero on cosine shift, metrics disagree</a:t>
-            </a:r>
-          </a:p>
-        </p:txBody>
-      </p:sp>
-      <p:sp>
-        <p:nvSpPr>
-          <p:cNvPr id="120" name="Shape 11"/>
+            </a:lvl1pPr>
+          </a:lstStyle>
+          <a:p>
+            <a:pPr/>
+            <a:r>
+              <a:t>All perturbations collapse onto the same region as disease/healthy references, which is consistent with pretrained cosine distance of only 0.003–0.006. Per-gene panels show both VAT1L and SCN4B cosine shifts for each gene.</a:t>
+            </a:r>
+          </a:p>
+        </p:txBody>
+      </p:sp>
+      <p:sp>
+        <p:nvSpPr>
+          <p:cNvPr id="121" name="Shape 11"/>
           <p:cNvSpPr/>
           <p:nvPr/>
         </p:nvSpPr>
         <p:spPr>
           <a:xfrm>
-            <a:off x="274319" y="1837944"/>
-            <a:ext cx="4114803" cy="731522"/>
+            <a:off x="267968" y="1837944"/>
+            <a:ext cx="4121155" cy="913611"/>
           </a:xfrm>
           <a:prstGeom prst="rect">
             <a:avLst/>
@@ -5868,14 +5911,14 @@
       </p:sp>
       <p:sp>
         <p:nvSpPr>
-          <p:cNvPr id="121" name="Shape 12"/>
+          <p:cNvPr id="122" name="Shape 12"/>
           <p:cNvSpPr/>
           <p:nvPr/>
         </p:nvSpPr>
         <p:spPr>
           <a:xfrm>
             <a:off x="347472" y="2057399"/>
-            <a:ext cx="274323" cy="274323"/>
+            <a:ext cx="274325" cy="274325"/>
           </a:xfrm>
           <a:prstGeom prst="ellipse">
             <a:avLst/>
@@ -5906,13 +5949,13 @@
       </p:sp>
       <p:sp>
         <p:nvSpPr>
-          <p:cNvPr id="122" name="Text 13"/>
+          <p:cNvPr id="123" name="Text 13"/>
           <p:cNvSpPr txBox="1"/>
           <p:nvPr/>
         </p:nvSpPr>
         <p:spPr>
           <a:xfrm>
-            <a:off x="347472" y="2126023"/>
+            <a:off x="347472" y="2126022"/>
             <a:ext cx="274322" cy="137072"/>
           </a:xfrm>
           <a:prstGeom prst="rect">
@@ -5954,13 +5997,13 @@
       </p:sp>
       <p:sp>
         <p:nvSpPr>
-          <p:cNvPr id="123" name="Text 14"/>
+          <p:cNvPr id="124" name="Text 14"/>
           <p:cNvSpPr txBox="1"/>
           <p:nvPr/>
         </p:nvSpPr>
         <p:spPr>
           <a:xfrm>
-            <a:off x="694944" y="1939034"/>
+            <a:off x="694944" y="1926333"/>
             <a:ext cx="3621024" cy="127001"/>
           </a:xfrm>
           <a:prstGeom prst="rect">
@@ -5995,21 +6038,21 @@
           <a:p>
             <a:pPr/>
             <a:r>
-              <a:t>Panel B: Multi-Metric Concordance</a:t>
-            </a:r>
-          </a:p>
-        </p:txBody>
-      </p:sp>
-      <p:sp>
-        <p:nvSpPr>
-          <p:cNvPr id="124" name="Text Description 2"/>
+              <a:t>PCA: Disease-to-Healthy Axis (PC1 = 35.4% variance)</a:t>
+            </a:r>
+          </a:p>
+        </p:txBody>
+      </p:sp>
+      <p:sp>
+        <p:nvSpPr>
+          <p:cNvPr id="125" name="Text Description 2"/>
           <p:cNvSpPr txBox="1"/>
           <p:nvPr/>
         </p:nvSpPr>
         <p:spPr>
           <a:xfrm>
-            <a:off x="694944" y="2079034"/>
-            <a:ext cx="3621024" cy="485578"/>
+            <a:off x="694944" y="2066333"/>
+            <a:ext cx="3621024" cy="638970"/>
           </a:xfrm>
           <a:prstGeom prst="rect">
             <a:avLst/>
@@ -6041,7 +6084,11 @@
               </a:defRPr>
             </a:pPr>
             <a:r>
-              <a:t>STMN2 leads with concordance score ~0.83: its signals agree in direction across all metrics</a:t>
+              <a:rPr b="1"/>
+              <a:t>Panel A</a:t>
+            </a:r>
+            <a:r>
+              <a:t>: VAT1L perturbation trajectories projected onto population-specific PCA. All genes cluster tightly due to small centroid separation. </a:t>
             </a:r>
           </a:p>
           <a:p>
@@ -6057,21 +6104,25 @@
               </a:defRPr>
             </a:pPr>
             <a:r>
-              <a:t>TARDBP (~0.65) and TBK1 (~0.55) are the only other genes above the 0.5 threshold</a:t>
-            </a:r>
-          </a:p>
-        </p:txBody>
-      </p:sp>
-      <p:sp>
-        <p:nvSpPr>
-          <p:cNvPr id="125" name="Shape 21"/>
+              <a:rPr b="1"/>
+              <a:t>Panel B</a:t>
+            </a:r>
+            <a:r>
+              <a:t>: Therapeutic specificity decomposition with both populations (◆ VAT1L, ■ SCN4B). STMN2 is a clear outlier in the therapeutic + high off-axis quadrant in both populations. Cross-population consistency visible for most genes.</a:t>
+            </a:r>
+          </a:p>
+        </p:txBody>
+      </p:sp>
+      <p:sp>
+        <p:nvSpPr>
+          <p:cNvPr id="126" name="Shape 21"/>
           <p:cNvSpPr/>
           <p:nvPr/>
         </p:nvSpPr>
         <p:spPr>
           <a:xfrm>
-            <a:off x="274319" y="2644647"/>
-            <a:ext cx="4114803" cy="731522"/>
+            <a:off x="271143" y="3576117"/>
+            <a:ext cx="4114805" cy="632620"/>
           </a:xfrm>
           <a:prstGeom prst="rect">
             <a:avLst/>
@@ -6102,14 +6153,14 @@
       </p:sp>
       <p:sp>
         <p:nvSpPr>
-          <p:cNvPr id="126" name="Shape 22"/>
+          <p:cNvPr id="127" name="Shape 22"/>
           <p:cNvSpPr/>
           <p:nvPr/>
         </p:nvSpPr>
         <p:spPr>
           <a:xfrm>
-            <a:off x="347472" y="2864103"/>
-            <a:ext cx="274323" cy="274323"/>
+            <a:off x="347472" y="3054603"/>
+            <a:ext cx="274325" cy="274325"/>
           </a:xfrm>
           <a:prstGeom prst="ellipse">
             <a:avLst/>
@@ -6140,13 +6191,13 @@
       </p:sp>
       <p:sp>
         <p:nvSpPr>
-          <p:cNvPr id="127" name="Text 23"/>
+          <p:cNvPr id="128" name="Text 23"/>
           <p:cNvSpPr txBox="1"/>
           <p:nvPr/>
         </p:nvSpPr>
         <p:spPr>
           <a:xfrm>
-            <a:off x="347472" y="2932727"/>
+            <a:off x="347472" y="3123226"/>
             <a:ext cx="274322" cy="137072"/>
           </a:xfrm>
           <a:prstGeom prst="rect">
@@ -6188,13 +6239,13 @@
       </p:sp>
       <p:sp>
         <p:nvSpPr>
-          <p:cNvPr id="128" name="Text 24"/>
+          <p:cNvPr id="129" name="Text 24"/>
           <p:cNvSpPr txBox="1"/>
           <p:nvPr/>
         </p:nvSpPr>
         <p:spPr>
           <a:xfrm>
-            <a:off x="694944" y="2745738"/>
+            <a:off x="694944" y="2910838"/>
             <a:ext cx="3621024" cy="127001"/>
           </a:xfrm>
           <a:prstGeom prst="rect">
@@ -6229,21 +6280,21 @@
           <a:p>
             <a:pPr/>
             <a:r>
-              <a:t>Panel C: Magnitude vs Specificity</a:t>
-            </a:r>
-          </a:p>
-        </p:txBody>
-      </p:sp>
-      <p:sp>
-        <p:nvSpPr>
-          <p:cNvPr id="129" name="Text Description 4"/>
+              <a:t>k-NN Neighbourhood Analysis (k=50)</a:t>
+            </a:r>
+          </a:p>
+        </p:txBody>
+      </p:sp>
+      <p:sp>
+        <p:nvSpPr>
+          <p:cNvPr id="130" name="Text Description 4"/>
           <p:cNvSpPr txBox="1"/>
           <p:nvPr/>
         </p:nvSpPr>
         <p:spPr>
           <a:xfrm>
-            <a:off x="694944" y="2885738"/>
-            <a:ext cx="3621024" cy="485578"/>
+            <a:off x="694944" y="3076238"/>
+            <a:ext cx="3621024" cy="358577"/>
           </a:xfrm>
           <a:prstGeom prst="rect">
             <a:avLst/>
@@ -6275,62 +6326,15 @@
               </a:defRPr>
             </a:pPr>
             <a:r>
-              <a:t>STMN2 is the only gene in the high-magnitude, high-specificity quadrant</a:t>
-            </a:r>
-          </a:p>
-          <a:p>
-            <a:pPr>
-              <a:defRPr sz="800">
-                <a:solidFill>
-                  <a:srgbClr val="4A6070"/>
-                </a:solidFill>
-                <a:latin typeface="+mj-lt"/>
-                <a:ea typeface="+mj-ea"/>
-                <a:cs typeface="+mj-cs"/>
-                <a:sym typeface="Calibri"/>
-              </a:defRPr>
-            </a:pPr>
-            <a:r>
-              <a:t>SARM1 has comparable magnitude to STMN2 but near-zero specificity (shift is mostly off-axis)</a:t>
-            </a:r>
-          </a:p>
-        </p:txBody>
-      </p:sp>
-      <p:sp>
-        <p:nvSpPr>
-          <p:cNvPr id="130" name="Shape 26"/>
-          <p:cNvSpPr/>
-          <p:nvPr/>
-        </p:nvSpPr>
-        <p:spPr>
-          <a:xfrm>
-            <a:off x="274319" y="3454398"/>
-            <a:ext cx="4114803" cy="731523"/>
-          </a:xfrm>
-          <a:prstGeom prst="rect">
-            <a:avLst/>
-          </a:prstGeom>
-          <a:solidFill>
-            <a:srgbClr val="EEF4F8"/>
-          </a:solidFill>
-          <a:ln w="6350">
-            <a:solidFill>
-              <a:srgbClr val="D0DDE8"/>
-            </a:solidFill>
-          </a:ln>
-        </p:spPr>
-        <p:txBody>
-          <a:bodyPr lIns="45718" tIns="45718" rIns="45718" bIns="45718"/>
-          <a:lstStyle/>
-          <a:p>
-            <a:pPr>
-              <a:defRPr>
-                <a:latin typeface="+mj-lt"/>
-                <a:ea typeface="+mj-ea"/>
-                <a:cs typeface="+mj-cs"/>
-                <a:sym typeface="Calibri"/>
-              </a:defRPr>
-            </a:pPr>
+              <a:t>Healthy Neighbour Fraction (HNF) computed for both VAT1L and SCN4B disease perturbations against respective baselines. All ΔHNF values near zero (</a:t>
+            </a:r>
+            <a:r>
+              <a:rPr i="1"/>
+              <a:t>expected at pretrained resolution</a:t>
+            </a:r>
+            <a:r>
+              <a:t>). Will become informative after fine-tuning.</a:t>
+            </a:r>
           </a:p>
         </p:txBody>
       </p:sp>
@@ -6342,8 +6346,8 @@
         </p:nvSpPr>
         <p:spPr>
           <a:xfrm>
-            <a:off x="347472" y="3623054"/>
-            <a:ext cx="274323" cy="274323"/>
+            <a:off x="347472" y="3699254"/>
+            <a:ext cx="274325" cy="274325"/>
           </a:xfrm>
           <a:prstGeom prst="ellipse">
             <a:avLst/>
@@ -6380,7 +6384,7 @@
         </p:nvSpPr>
         <p:spPr>
           <a:xfrm>
-            <a:off x="347472" y="3691680"/>
+            <a:off x="347472" y="3767880"/>
             <a:ext cx="274322" cy="137071"/>
           </a:xfrm>
           <a:prstGeom prst="rect">
@@ -6428,7 +6432,7 @@
         </p:nvSpPr>
         <p:spPr>
           <a:xfrm>
-            <a:off x="694944" y="3555491"/>
+            <a:off x="694944" y="3631691"/>
             <a:ext cx="3621024" cy="127001"/>
           </a:xfrm>
           <a:prstGeom prst="rect">
@@ -6463,7 +6467,7 @@
           <a:p>
             <a:pPr/>
             <a:r>
-              <a:t>Panel D: Integrated Heatmap</a:t>
+              <a:t>Hierarchical Clustering of Displacement Vectors</a:t>
             </a:r>
           </a:p>
         </p:txBody>
@@ -6476,8 +6480,8 @@
         </p:nvSpPr>
         <p:spPr>
           <a:xfrm>
-            <a:off x="694944" y="3695491"/>
-            <a:ext cx="3621024" cy="485578"/>
+            <a:off x="694944" y="3771691"/>
+            <a:ext cx="3621024" cy="358577"/>
           </a:xfrm>
           <a:prstGeom prst="rect">
             <a:avLst/>
@@ -6495,9 +6499,8 @@
           <a:bodyPr lIns="0" tIns="0" rIns="0" bIns="0">
             <a:spAutoFit/>
           </a:bodyPr>
-          <a:lstStyle/>
-          <a:p>
-            <a:pPr>
+          <a:lstStyle>
+            <a:lvl1pPr>
               <a:defRPr sz="800">
                 <a:solidFill>
                   <a:srgbClr val="4A6070"/>
@@ -6507,25 +6510,12 @@
                 <a:cs typeface="+mj-cs"/>
                 <a:sym typeface="Calibri"/>
               </a:defRPr>
-            </a:pPr>
-            <a:r>
-              <a:t>STMN2 is the only gene with positive Z-scores across all five metrics</a:t>
-            </a:r>
-          </a:p>
-          <a:p>
-            <a:pPr>
-              <a:defRPr sz="800">
-                <a:solidFill>
-                  <a:srgbClr val="4A6070"/>
-                </a:solidFill>
-                <a:latin typeface="+mj-lt"/>
-                <a:ea typeface="+mj-ea"/>
-                <a:cs typeface="+mj-cs"/>
-                <a:sym typeface="Calibri"/>
-              </a:defRPr>
-            </a:pPr>
-            <a:r>
-              <a:t>Every other gene has at least one strongly negative (red) cell… no other gene is consistent across all dimensions</a:t>
+            </a:lvl1pPr>
+          </a:lstStyle>
+          <a:p>
+            <a:pPr/>
+            <a:r>
+              <a:t>STMN2 and SARM1 co-cluster (top rescue candidates). TARDBP clusters with ACTB (both near-zero displacement). Biological axes not cleanly recovered, signal-to-noise limitation of pretrained embeddings.</a:t>
             </a:r>
           </a:p>
         </p:txBody>
@@ -6538,8 +6528,8 @@
         </p:nvSpPr>
         <p:spPr>
           <a:xfrm>
-            <a:off x="4663440" y="804671"/>
-            <a:ext cx="4206242" cy="4114803"/>
+            <a:off x="4663440" y="766570"/>
+            <a:ext cx="4010664" cy="3610360"/>
           </a:xfrm>
           <a:prstGeom prst="rect">
             <a:avLst/>
@@ -6593,8 +6583,8 @@
         </p:blipFill>
         <p:spPr>
           <a:xfrm>
-            <a:off x="4709159" y="839999"/>
-            <a:ext cx="4114802" cy="3886203"/>
+            <a:off x="4709159" y="801899"/>
+            <a:ext cx="3667237" cy="3463502"/>
           </a:xfrm>
           <a:prstGeom prst="rect">
             <a:avLst/>
@@ -6604,6 +6594,322 @@
           </a:ln>
         </p:spPr>
       </p:pic>
+      <p:sp>
+        <p:nvSpPr>
+          <p:cNvPr id="137" name="Shape 26"/>
+          <p:cNvSpPr/>
+          <p:nvPr/>
+        </p:nvSpPr>
+        <p:spPr>
+          <a:xfrm>
+            <a:off x="271143" y="4265753"/>
+            <a:ext cx="4114805" cy="731524"/>
+          </a:xfrm>
+          <a:prstGeom prst="rect">
+            <a:avLst/>
+          </a:prstGeom>
+          <a:solidFill>
+            <a:srgbClr val="EEF4F8"/>
+          </a:solidFill>
+          <a:ln w="6350">
+            <a:solidFill>
+              <a:srgbClr val="D0DDE8"/>
+            </a:solidFill>
+          </a:ln>
+        </p:spPr>
+        <p:txBody>
+          <a:bodyPr lIns="45718" tIns="45718" rIns="45718" bIns="45718"/>
+          <a:lstStyle/>
+          <a:p>
+            <a:pPr>
+              <a:defRPr>
+                <a:latin typeface="+mj-lt"/>
+                <a:ea typeface="+mj-ea"/>
+                <a:cs typeface="+mj-cs"/>
+                <a:sym typeface="Calibri"/>
+              </a:defRPr>
+            </a:pPr>
+          </a:p>
+        </p:txBody>
+      </p:sp>
+      <p:sp>
+        <p:nvSpPr>
+          <p:cNvPr id="138" name="Shape 22"/>
+          <p:cNvSpPr/>
+          <p:nvPr/>
+        </p:nvSpPr>
+        <p:spPr>
+          <a:xfrm>
+            <a:off x="344297" y="4515461"/>
+            <a:ext cx="274325" cy="274325"/>
+          </a:xfrm>
+          <a:prstGeom prst="ellipse">
+            <a:avLst/>
+          </a:prstGeom>
+          <a:solidFill>
+            <a:srgbClr val="0E7C7B"/>
+          </a:solidFill>
+          <a:ln w="12700">
+            <a:solidFill>
+              <a:srgbClr val="0E7C7B"/>
+            </a:solidFill>
+          </a:ln>
+        </p:spPr>
+        <p:txBody>
+          <a:bodyPr lIns="45718" tIns="45718" rIns="45718" bIns="45718"/>
+          <a:lstStyle/>
+          <a:p>
+            <a:pPr>
+              <a:defRPr>
+                <a:latin typeface="+mj-lt"/>
+                <a:ea typeface="+mj-ea"/>
+                <a:cs typeface="+mj-cs"/>
+                <a:sym typeface="Calibri"/>
+              </a:defRPr>
+            </a:pPr>
+          </a:p>
+        </p:txBody>
+      </p:sp>
+      <p:sp>
+        <p:nvSpPr>
+          <p:cNvPr id="139" name="Text 23"/>
+          <p:cNvSpPr txBox="1"/>
+          <p:nvPr/>
+        </p:nvSpPr>
+        <p:spPr>
+          <a:xfrm>
+            <a:off x="344297" y="4571385"/>
+            <a:ext cx="274322" cy="137072"/>
+          </a:xfrm>
+          <a:prstGeom prst="rect">
+            <a:avLst/>
+          </a:prstGeom>
+          <a:ln w="12700">
+            <a:miter lim="400000"/>
+          </a:ln>
+          <a:extLst>
+            <a:ext uri="{C572A759-6A51-4108-AA02-DFA0A04FC94B}">
+              <ma14:wrappingTextBoxFlag xmlns:ma14="http://schemas.microsoft.com/office/mac/drawingml/2011/main" val="1"/>
+            </a:ext>
+          </a:extLst>
+        </p:spPr>
+        <p:txBody>
+          <a:bodyPr lIns="0" tIns="0" rIns="0" bIns="0" anchor="ctr">
+            <a:spAutoFit/>
+          </a:bodyPr>
+          <a:lstStyle>
+            <a:lvl1pPr algn="ctr">
+              <a:defRPr b="1" sz="1000">
+                <a:solidFill>
+                  <a:srgbClr val="FFFFFF"/>
+                </a:solidFill>
+                <a:latin typeface="+mj-lt"/>
+                <a:ea typeface="+mj-ea"/>
+                <a:cs typeface="+mj-cs"/>
+                <a:sym typeface="Calibri"/>
+              </a:defRPr>
+            </a:lvl1pPr>
+          </a:lstStyle>
+          <a:p>
+            <a:pPr/>
+            <a:r>
+              <a:t>5</a:t>
+            </a:r>
+          </a:p>
+        </p:txBody>
+      </p:sp>
+      <p:sp>
+        <p:nvSpPr>
+          <p:cNvPr id="140" name="Text 24"/>
+          <p:cNvSpPr txBox="1"/>
+          <p:nvPr/>
+        </p:nvSpPr>
+        <p:spPr>
+          <a:xfrm>
+            <a:off x="691769" y="4320896"/>
+            <a:ext cx="3621025" cy="127001"/>
+          </a:xfrm>
+          <a:prstGeom prst="rect">
+            <a:avLst/>
+          </a:prstGeom>
+          <a:ln w="12700">
+            <a:miter lim="400000"/>
+          </a:ln>
+          <a:extLst>
+            <a:ext uri="{C572A759-6A51-4108-AA02-DFA0A04FC94B}">
+              <ma14:wrappingTextBoxFlag xmlns:ma14="http://schemas.microsoft.com/office/mac/drawingml/2011/main" val="1"/>
+            </a:ext>
+          </a:extLst>
+        </p:spPr>
+        <p:txBody>
+          <a:bodyPr lIns="0" tIns="0" rIns="0" bIns="0" anchor="ctr">
+            <a:spAutoFit/>
+          </a:bodyPr>
+          <a:lstStyle>
+            <a:lvl1pPr>
+              <a:defRPr b="1" sz="900">
+                <a:solidFill>
+                  <a:srgbClr val="0A2342"/>
+                </a:solidFill>
+                <a:latin typeface="+mj-lt"/>
+                <a:ea typeface="+mj-ea"/>
+                <a:cs typeface="+mj-cs"/>
+                <a:sym typeface="Calibri"/>
+              </a:defRPr>
+            </a:lvl1pPr>
+          </a:lstStyle>
+          <a:p>
+            <a:pPr/>
+            <a:r>
+              <a:t>Bidirectional Consistency</a:t>
+            </a:r>
+          </a:p>
+        </p:txBody>
+      </p:sp>
+      <p:sp>
+        <p:nvSpPr>
+          <p:cNvPr id="141" name="Text Description 4"/>
+          <p:cNvSpPr txBox="1"/>
+          <p:nvPr/>
+        </p:nvSpPr>
+        <p:spPr>
+          <a:xfrm>
+            <a:off x="691769" y="4473596"/>
+            <a:ext cx="3621025" cy="485578"/>
+          </a:xfrm>
+          <a:prstGeom prst="rect">
+            <a:avLst/>
+          </a:prstGeom>
+          <a:ln w="12700">
+            <a:miter lim="400000"/>
+          </a:ln>
+          <a:extLst>
+            <a:ext uri="{C572A759-6A51-4108-AA02-DFA0A04FC94B}">
+              <ma14:wrappingTextBoxFlag xmlns:ma14="http://schemas.microsoft.com/office/mac/drawingml/2011/main" val="1"/>
+            </a:ext>
+          </a:extLst>
+        </p:spPr>
+        <p:txBody>
+          <a:bodyPr lIns="0" tIns="0" rIns="0" bIns="0">
+            <a:spAutoFit/>
+          </a:bodyPr>
+          <a:lstStyle>
+            <a:lvl1pPr>
+              <a:defRPr sz="800">
+                <a:solidFill>
+                  <a:srgbClr val="4A6070"/>
+                </a:solidFill>
+                <a:latin typeface="+mj-lt"/>
+                <a:ea typeface="+mj-ea"/>
+                <a:cs typeface="+mj-cs"/>
+                <a:sym typeface="Calibri"/>
+              </a:defRPr>
+            </a:lvl1pPr>
+          </a:lstStyle>
+          <a:p>
+            <a:pPr/>
+            <a:r>
+              <a:t>Strongest mechanistic signal: 5 genes show opposing shifts in disease vs healthy cells (STMN2, SARM1, OPTN, TBK1, NEK1). 4 genes shift same direction in both conditions (UNC13A, POU3F1, DCTN1, DYNC1H1: context-independent effects). ACTB and TARDBP near-zero in both.</a:t>
+            </a:r>
+          </a:p>
+        </p:txBody>
+      </p:sp>
+      <p:sp>
+        <p:nvSpPr>
+          <p:cNvPr id="142" name="Text 24"/>
+          <p:cNvSpPr txBox="1"/>
+          <p:nvPr/>
+        </p:nvSpPr>
+        <p:spPr>
+          <a:xfrm>
+            <a:off x="4660738" y="4496598"/>
+            <a:ext cx="3621024" cy="127001"/>
+          </a:xfrm>
+          <a:prstGeom prst="rect">
+            <a:avLst/>
+          </a:prstGeom>
+          <a:ln w="12700">
+            <a:miter lim="400000"/>
+          </a:ln>
+          <a:extLst>
+            <a:ext uri="{C572A759-6A51-4108-AA02-DFA0A04FC94B}">
+              <ma14:wrappingTextBoxFlag xmlns:ma14="http://schemas.microsoft.com/office/mac/drawingml/2011/main" val="1"/>
+            </a:ext>
+          </a:extLst>
+        </p:spPr>
+        <p:txBody>
+          <a:bodyPr lIns="0" tIns="0" rIns="0" bIns="0" anchor="ctr">
+            <a:spAutoFit/>
+          </a:bodyPr>
+          <a:lstStyle>
+            <a:lvl1pPr>
+              <a:defRPr b="1" sz="900">
+                <a:solidFill>
+                  <a:srgbClr val="0A2342"/>
+                </a:solidFill>
+                <a:latin typeface="+mj-lt"/>
+                <a:ea typeface="+mj-ea"/>
+                <a:cs typeface="+mj-cs"/>
+                <a:sym typeface="Calibri"/>
+              </a:defRPr>
+            </a:lvl1pPr>
+          </a:lstStyle>
+          <a:p>
+            <a:pPr/>
+            <a:r>
+              <a:t>KEY FINDING</a:t>
+            </a:r>
+          </a:p>
+        </p:txBody>
+      </p:sp>
+      <p:sp>
+        <p:nvSpPr>
+          <p:cNvPr id="143" name="Text Description 4"/>
+          <p:cNvSpPr txBox="1"/>
+          <p:nvPr/>
+        </p:nvSpPr>
+        <p:spPr>
+          <a:xfrm>
+            <a:off x="4660738" y="4636598"/>
+            <a:ext cx="3990668" cy="358578"/>
+          </a:xfrm>
+          <a:prstGeom prst="rect">
+            <a:avLst/>
+          </a:prstGeom>
+          <a:ln w="12700">
+            <a:miter lim="400000"/>
+          </a:ln>
+          <a:extLst>
+            <a:ext uri="{C572A759-6A51-4108-AA02-DFA0A04FC94B}">
+              <ma14:wrappingTextBoxFlag xmlns:ma14="http://schemas.microsoft.com/office/mac/drawingml/2011/main" val="1"/>
+            </a:ext>
+          </a:extLst>
+        </p:spPr>
+        <p:txBody>
+          <a:bodyPr lIns="0" tIns="0" rIns="0" bIns="0">
+            <a:spAutoFit/>
+          </a:bodyPr>
+          <a:lstStyle>
+            <a:lvl1pPr>
+              <a:defRPr sz="800">
+                <a:solidFill>
+                  <a:srgbClr val="4A6070"/>
+                </a:solidFill>
+                <a:latin typeface="+mj-lt"/>
+                <a:ea typeface="+mj-ea"/>
+                <a:cs typeface="+mj-cs"/>
+                <a:sym typeface="Calibri"/>
+              </a:defRPr>
+            </a:lvl1pPr>
+          </a:lstStyle>
+          <a:p>
+            <a:pPr/>
+            <a:r>
+              <a:t>STMN2 is the only gene with convergent signal across all analytical lenses: largest on-axis shift, highest concordance, bidirectional consistency, and cross-population replication between VAT1L and SCN4B.</a:t>
+            </a:r>
+          </a:p>
+        </p:txBody>
+      </p:sp>
     </p:spTree>
   </p:cSld>
   <p:clrMapOvr>
@@ -6639,7 +6945,45 @@
       </p:grpSpPr>
       <p:sp>
         <p:nvSpPr>
-          <p:cNvPr id="138" name="Shape 0"/>
+          <p:cNvPr id="145" name="Shape 207"/>
+          <p:cNvSpPr/>
+          <p:nvPr/>
+        </p:nvSpPr>
+        <p:spPr>
+          <a:xfrm>
+            <a:off x="4750395" y="3987212"/>
+            <a:ext cx="4190477" cy="838395"/>
+          </a:xfrm>
+          <a:prstGeom prst="rect">
+            <a:avLst/>
+          </a:prstGeom>
+          <a:solidFill>
+            <a:srgbClr val="EAF0F8"/>
+          </a:solidFill>
+          <a:ln>
+            <a:solidFill>
+              <a:srgbClr val="BACED9"/>
+            </a:solidFill>
+          </a:ln>
+        </p:spPr>
+        <p:txBody>
+          <a:bodyPr lIns="45718" tIns="45718" rIns="45718" bIns="45718"/>
+          <a:lstStyle/>
+          <a:p>
+            <a:pPr>
+              <a:defRPr>
+                <a:latin typeface="+mj-lt"/>
+                <a:ea typeface="+mj-ea"/>
+                <a:cs typeface="+mj-cs"/>
+                <a:sym typeface="Calibri"/>
+              </a:defRPr>
+            </a:pPr>
+          </a:p>
+        </p:txBody>
+      </p:sp>
+      <p:sp>
+        <p:nvSpPr>
+          <p:cNvPr id="146" name="Shape 0"/>
           <p:cNvSpPr/>
           <p:nvPr/>
         </p:nvSpPr>
@@ -6677,7 +7021,7 @@
       </p:sp>
       <p:sp>
         <p:nvSpPr>
-          <p:cNvPr id="139" name="Shape 1"/>
+          <p:cNvPr id="147" name="Shape 1"/>
           <p:cNvSpPr/>
           <p:nvPr/>
         </p:nvSpPr>
@@ -6715,14 +7059,14 @@
       </p:sp>
       <p:sp>
         <p:nvSpPr>
-          <p:cNvPr id="140" name="Text 2"/>
+          <p:cNvPr id="148" name="Text 2"/>
           <p:cNvSpPr txBox="1"/>
           <p:nvPr/>
         </p:nvSpPr>
         <p:spPr>
           <a:xfrm>
             <a:off x="-1" y="260647"/>
-            <a:ext cx="1234442" cy="137072"/>
+            <a:ext cx="1234442" cy="137071"/>
           </a:xfrm>
           <a:prstGeom prst="rect">
             <a:avLst/>
@@ -6763,7 +7107,7 @@
       </p:sp>
       <p:sp>
         <p:nvSpPr>
-          <p:cNvPr id="141" name="Text 3"/>
+          <p:cNvPr id="149" name="Text 3"/>
           <p:cNvSpPr txBox="1"/>
           <p:nvPr/>
         </p:nvSpPr>
@@ -6811,28 +7155,28 @@
       </p:sp>
       <p:grpSp>
         <p:nvGrpSpPr>
-          <p:cNvPr id="144" name="Shape 200"/>
+          <p:cNvPr id="152" name="Shape 200"/>
           <p:cNvGrpSpPr/>
           <p:nvPr/>
         </p:nvGrpSpPr>
         <p:grpSpPr>
           <a:xfrm>
-            <a:off x="274320" y="730000"/>
-            <a:ext cx="4200000" cy="190001"/>
+            <a:off x="274319" y="729999"/>
+            <a:ext cx="4200002" cy="190004"/>
             <a:chOff x="0" y="0"/>
-            <a:chExt cx="4199999" cy="190000"/>
+            <a:chExt cx="4200001" cy="190002"/>
           </a:xfrm>
         </p:grpSpPr>
         <p:sp>
           <p:nvSpPr>
-            <p:cNvPr id="142" name="Rectangle"/>
+            <p:cNvPr id="150" name="Rectangle"/>
             <p:cNvSpPr/>
             <p:nvPr/>
           </p:nvSpPr>
           <p:spPr>
             <a:xfrm>
-              <a:off x="0" y="-1"/>
-              <a:ext cx="4200000" cy="190002"/>
+              <a:off x="-1" y="-1"/>
+              <a:ext cx="4200002" cy="190003"/>
             </a:xfrm>
             <a:prstGeom prst="rect">
               <a:avLst/>
@@ -6868,14 +7212,14 @@
         </p:sp>
         <p:sp>
           <p:nvSpPr>
-            <p:cNvPr id="143" name="KEY FINDINGS and NEXT STEPS"/>
+            <p:cNvPr id="151" name="KEY FINDINGS and NEXT STEPS"/>
             <p:cNvSpPr txBox="1"/>
             <p:nvPr/>
           </p:nvSpPr>
           <p:spPr>
             <a:xfrm>
               <a:off x="74930" y="3605"/>
-              <a:ext cx="4050140" cy="182790"/>
+              <a:ext cx="4050141" cy="182789"/>
             </a:xfrm>
             <a:prstGeom prst="rect">
               <a:avLst/>
@@ -6912,7 +7256,7 @@
             <a:p>
               <a:pPr/>
               <a:r>
-                <a:t>KEY FINDINGS and NEXT STEPS</a:t>
+                <a:t>COMPOSITE RANKING — 6 METRICS × 10 GENES</a:t>
               </a:r>
             </a:p>
           </p:txBody>
@@ -6920,90 +7264,14 @@
       </p:grpSp>
       <p:sp>
         <p:nvSpPr>
-          <p:cNvPr id="145" name="Shape 201"/>
-          <p:cNvSpPr/>
-          <p:nvPr/>
-        </p:nvSpPr>
-        <p:spPr>
-          <a:xfrm>
-            <a:off x="274320" y="1544600"/>
-            <a:ext cx="4200000" cy="504561"/>
-          </a:xfrm>
-          <a:prstGeom prst="rect">
-            <a:avLst/>
-          </a:prstGeom>
-          <a:solidFill>
-            <a:srgbClr val="E4F3F3"/>
-          </a:solidFill>
-          <a:ln>
-            <a:solidFill>
-              <a:srgbClr val="B8DFE0"/>
-            </a:solidFill>
-          </a:ln>
-        </p:spPr>
-        <p:txBody>
-          <a:bodyPr lIns="45718" tIns="45718" rIns="45718" bIns="45718"/>
-          <a:lstStyle/>
-          <a:p>
-            <a:pPr>
-              <a:defRPr>
-                <a:latin typeface="+mj-lt"/>
-                <a:ea typeface="+mj-ea"/>
-                <a:cs typeface="+mj-cs"/>
-                <a:sym typeface="Calibri"/>
-              </a:defRPr>
-            </a:pPr>
-          </a:p>
-        </p:txBody>
-      </p:sp>
-      <p:sp>
-        <p:nvSpPr>
-          <p:cNvPr id="146" name="Shape 202"/>
-          <p:cNvSpPr/>
-          <p:nvPr/>
-        </p:nvSpPr>
-        <p:spPr>
-          <a:xfrm>
-            <a:off x="274320" y="1544600"/>
-            <a:ext cx="72001" cy="452900"/>
-          </a:xfrm>
-          <a:prstGeom prst="rect">
-            <a:avLst/>
-          </a:prstGeom>
-          <a:solidFill>
-            <a:srgbClr val="0E7C7B"/>
-          </a:solidFill>
-          <a:ln w="12700">
-            <a:solidFill>
-              <a:srgbClr val="0E7C7B"/>
-            </a:solidFill>
-          </a:ln>
-        </p:spPr>
-        <p:txBody>
-          <a:bodyPr lIns="45718" tIns="45718" rIns="45718" bIns="45718"/>
-          <a:lstStyle/>
-          <a:p>
-            <a:pPr>
-              <a:defRPr>
-                <a:latin typeface="+mj-lt"/>
-                <a:ea typeface="+mj-ea"/>
-                <a:cs typeface="+mj-cs"/>
-                <a:sym typeface="Calibri"/>
-              </a:defRPr>
-            </a:pPr>
-          </a:p>
-        </p:txBody>
-      </p:sp>
-      <p:sp>
-        <p:nvSpPr>
-          <p:cNvPr id="147" name="Text 203"/>
+          <p:cNvPr id="153" name="Text 203"/>
           <p:cNvSpPr txBox="1"/>
           <p:nvPr/>
         </p:nvSpPr>
         <p:spPr>
           <a:xfrm>
-            <a:off x="389179" y="1565740"/>
-            <a:ext cx="4062282" cy="322580"/>
+            <a:off x="389179" y="1565739"/>
+            <a:ext cx="4062282" cy="322579"/>
           </a:xfrm>
           <a:prstGeom prst="rect">
             <a:avLst/>
@@ -7061,14 +7329,14 @@
       </p:sp>
       <p:sp>
         <p:nvSpPr>
-          <p:cNvPr id="148" name="Shape 204"/>
+          <p:cNvPr id="154" name="Shape 204"/>
           <p:cNvSpPr/>
           <p:nvPr/>
         </p:nvSpPr>
         <p:spPr>
           <a:xfrm>
-            <a:off x="274320" y="2043099"/>
-            <a:ext cx="4190475" cy="550899"/>
+            <a:off x="274319" y="1877998"/>
+            <a:ext cx="4190476" cy="661546"/>
           </a:xfrm>
           <a:prstGeom prst="rect">
             <a:avLst/>
@@ -7099,14 +7367,14 @@
       </p:sp>
       <p:sp>
         <p:nvSpPr>
-          <p:cNvPr id="149" name="Shape 205"/>
+          <p:cNvPr id="155" name="Shape 205"/>
           <p:cNvSpPr/>
           <p:nvPr/>
         </p:nvSpPr>
         <p:spPr>
           <a:xfrm>
-            <a:off x="274320" y="2043099"/>
-            <a:ext cx="72001" cy="550899"/>
+            <a:off x="274320" y="1877998"/>
+            <a:ext cx="72002" cy="661546"/>
           </a:xfrm>
           <a:prstGeom prst="rect">
             <a:avLst/>
@@ -7137,14 +7405,14 @@
       </p:sp>
       <p:sp>
         <p:nvSpPr>
-          <p:cNvPr id="150" name="Shape 207"/>
+          <p:cNvPr id="156" name="Shape 207"/>
           <p:cNvSpPr/>
           <p:nvPr/>
         </p:nvSpPr>
         <p:spPr>
           <a:xfrm>
-            <a:off x="274320" y="2613199"/>
-            <a:ext cx="4190475" cy="554074"/>
+            <a:off x="274319" y="2575099"/>
+            <a:ext cx="4190476" cy="515973"/>
           </a:xfrm>
           <a:prstGeom prst="rect">
             <a:avLst/>
@@ -7175,14 +7443,14 @@
       </p:sp>
       <p:sp>
         <p:nvSpPr>
-          <p:cNvPr id="151" name="Shape 208"/>
+          <p:cNvPr id="157" name="Shape 208"/>
           <p:cNvSpPr/>
           <p:nvPr/>
         </p:nvSpPr>
         <p:spPr>
           <a:xfrm>
-            <a:off x="274320" y="2613199"/>
-            <a:ext cx="72001" cy="554074"/>
+            <a:off x="274320" y="2575099"/>
+            <a:ext cx="72002" cy="515973"/>
           </a:xfrm>
           <a:prstGeom prst="rect">
             <a:avLst/>
@@ -7213,14 +7481,14 @@
       </p:sp>
       <p:sp>
         <p:nvSpPr>
-          <p:cNvPr id="152" name="Text 209"/>
+          <p:cNvPr id="158" name="Text 209"/>
           <p:cNvSpPr txBox="1"/>
           <p:nvPr/>
         </p:nvSpPr>
         <p:spPr>
           <a:xfrm>
-            <a:off x="389179" y="2634341"/>
-            <a:ext cx="4062282" cy="322579"/>
+            <a:off x="389179" y="2601946"/>
+            <a:ext cx="4062282" cy="462279"/>
           </a:xfrm>
           <a:prstGeom prst="rect">
             <a:avLst/>
@@ -7252,7 +7520,7 @@
               </a:defRPr>
             </a:pPr>
             <a:r>
-              <a:t>OPTN KD</a:t>
+              <a:t>Tier 3: Mechanism Validators</a:t>
             </a:r>
           </a:p>
           <a:p>
@@ -7260,7 +7528,7 @@
               <a:lnSpc>
                 <a:spcPts val="1100"/>
               </a:lnSpc>
-              <a:defRPr i="1" sz="800">
+              <a:defRPr sz="800">
                 <a:solidFill>
                   <a:srgbClr val="2A5A6A"/>
                 </a:solidFill>
@@ -7271,21 +7539,21 @@
               </a:defRPr>
             </a:pPr>
             <a:r>
-              <a:t>validate autophagy-axis rescue in VAT1L+ and SCN4B+ cells</a:t>
-            </a:r>
-          </a:p>
-        </p:txBody>
-      </p:sp>
-      <p:sp>
-        <p:nvSpPr>
-          <p:cNvPr id="153" name="Text 251"/>
+              <a:t>DYNC1H1 (0.461), DCTN1 (0.335): KD worsens both disease and healthy cells → context-independent. Confirms axonal transport pathway.</a:t>
+            </a:r>
+          </a:p>
+        </p:txBody>
+      </p:sp>
+      <p:sp>
+        <p:nvSpPr>
+          <p:cNvPr id="159" name="Text 251"/>
           <p:cNvSpPr txBox="1"/>
           <p:nvPr/>
         </p:nvSpPr>
         <p:spPr>
           <a:xfrm>
-            <a:off x="4842860" y="5799999"/>
-            <a:ext cx="4003960" cy="265092"/>
+            <a:off x="4842859" y="5799999"/>
+            <a:ext cx="4003960" cy="265091"/>
           </a:xfrm>
           <a:prstGeom prst="rect">
             <a:avLst/>
@@ -7326,7 +7594,7 @@
       </p:sp>
       <p:pic>
         <p:nvPicPr>
-          <p:cNvPr id="154" name="task4_ranking_decomposition.png" descr="task4_ranking_decomposition.png"/>
+          <p:cNvPr id="160" name="task4_ranking_decomposition.png" descr="task4_ranking_decomposition.png"/>
           <p:cNvPicPr>
             <a:picLocks noChangeAspect="1"/>
           </p:cNvPicPr>
@@ -7343,8 +7611,8 @@
         </p:blipFill>
         <p:spPr>
           <a:xfrm>
-            <a:off x="4690896" y="785695"/>
-            <a:ext cx="3872303" cy="3378083"/>
+            <a:off x="5024509" y="722195"/>
+            <a:ext cx="3408187" cy="2973201"/>
           </a:xfrm>
           <a:prstGeom prst="rect">
             <a:avLst/>
@@ -7356,14 +7624,14 @@
       </p:pic>
       <p:sp>
         <p:nvSpPr>
-          <p:cNvPr id="155" name="Text 203"/>
+          <p:cNvPr id="161" name="Text 203"/>
           <p:cNvSpPr txBox="1"/>
           <p:nvPr/>
         </p:nvSpPr>
         <p:spPr>
           <a:xfrm>
-            <a:off x="368580" y="2069018"/>
-            <a:ext cx="4062280" cy="322579"/>
+            <a:off x="389180" y="1893344"/>
+            <a:ext cx="4062280" cy="601979"/>
           </a:xfrm>
           <a:prstGeom prst="rect">
             <a:avLst/>
@@ -7395,7 +7663,7 @@
               </a:defRPr>
             </a:pPr>
             <a:r>
-              <a:t>SARM1 KD</a:t>
+              <a:t>Tier 2: Consistent Rescue</a:t>
             </a:r>
           </a:p>
           <a:p>
@@ -7403,7 +7671,7 @@
               <a:lnSpc>
                 <a:spcPts val="1100"/>
               </a:lnSpc>
-              <a:defRPr i="1" sz="800">
+              <a:defRPr sz="800">
                 <a:solidFill>
                   <a:srgbClr val="2A5A6A"/>
                 </a:solidFill>
@@ -7414,21 +7682,21 @@
               </a:defRPr>
             </a:pPr>
             <a:r>
-              <a:t>VAT1L+ neurons using clinical-stage NADase inhibitor</a:t>
-            </a:r>
-          </a:p>
-        </p:txBody>
-      </p:sp>
-      <p:sp>
-        <p:nvSpPr>
-          <p:cNvPr id="156" name="Shape 201"/>
+              <a:t>OPTN KD (0.634): bidirectional ✓, p=0.038*. TARDBP KD (0.427): bidirectional ✓ but near-zero shift (TDP-43 is invisible to rank encoding (ubiquitous → low rank)). Model detects pathway through STMN2, not the hub gene. TBK1 KD (0.417): bidirectional ✓, additive with OPTN.</a:t>
+            </a:r>
+          </a:p>
+        </p:txBody>
+      </p:sp>
+      <p:sp>
+        <p:nvSpPr>
+          <p:cNvPr id="162" name="Shape 201"/>
           <p:cNvSpPr/>
           <p:nvPr/>
         </p:nvSpPr>
         <p:spPr>
           <a:xfrm>
-            <a:off x="275113" y="994178"/>
-            <a:ext cx="4200001" cy="504561"/>
+            <a:off x="275113" y="956077"/>
+            <a:ext cx="4200002" cy="893063"/>
           </a:xfrm>
           <a:prstGeom prst="rect">
             <a:avLst/>
@@ -7459,14 +7727,14 @@
       </p:sp>
       <p:sp>
         <p:nvSpPr>
-          <p:cNvPr id="157" name="Shape 202"/>
+          <p:cNvPr id="163" name="Shape 202"/>
           <p:cNvSpPr/>
           <p:nvPr/>
         </p:nvSpPr>
         <p:spPr>
           <a:xfrm>
-            <a:off x="275113" y="994178"/>
-            <a:ext cx="72001" cy="497691"/>
+            <a:off x="275113" y="956077"/>
+            <a:ext cx="72002" cy="886806"/>
           </a:xfrm>
           <a:prstGeom prst="rect">
             <a:avLst/>
@@ -7476,7 +7744,7 @@
           </a:solidFill>
           <a:ln w="12700">
             <a:solidFill>
-              <a:srgbClr val="0E7C7B"/>
+              <a:srgbClr val="7A1919"/>
             </a:solidFill>
           </a:ln>
         </p:spPr>
@@ -7497,14 +7765,14 @@
       </p:sp>
       <p:sp>
         <p:nvSpPr>
-          <p:cNvPr id="158" name="Text 203"/>
+          <p:cNvPr id="164" name="Text 203"/>
           <p:cNvSpPr txBox="1"/>
           <p:nvPr/>
         </p:nvSpPr>
         <p:spPr>
           <a:xfrm>
-            <a:off x="389973" y="1015319"/>
-            <a:ext cx="4062281" cy="462279"/>
+            <a:off x="389972" y="964519"/>
+            <a:ext cx="4062283" cy="850779"/>
           </a:xfrm>
           <a:prstGeom prst="rect">
             <a:avLst/>
@@ -7536,9 +7804,568 @@
               </a:defRPr>
             </a:pPr>
             <a:r>
-              <a:t>FINE-TUNE! </a:t>
-            </a:r>
-          </a:p>
+              <a:t>Tier 1: Strong Rescue </a:t>
+            </a:r>
+          </a:p>
+          <a:p>
+            <a:pPr>
+              <a:defRPr sz="800">
+                <a:solidFill>
+                  <a:srgbClr val="4A6070"/>
+                </a:solidFill>
+                <a:latin typeface="+mj-lt"/>
+                <a:ea typeface="+mj-ea"/>
+                <a:cs typeface="+mj-cs"/>
+                <a:sym typeface="Calibri"/>
+              </a:defRPr>
+            </a:pPr>
+            <a:r>
+              <a:t>#1 STMN2 Largest rescue shift, bidirectional ✓, cross-pop ✓, dose-response. Only gene satisfying all 6 metrics. Near-zero log2FC (−0.13) because pathology is isoform-level (cryptic exon), not total expression. QRL-201 ASO in Phase 1/2.</a:t>
+            </a:r>
+          </a:p>
+          <a:p>
+            <a:pPr>
+              <a:defRPr sz="800">
+                <a:solidFill>
+                  <a:srgbClr val="4A6070"/>
+                </a:solidFill>
+                <a:latin typeface="+mj-lt"/>
+                <a:ea typeface="+mj-ea"/>
+                <a:cs typeface="+mj-cs"/>
+                <a:sym typeface="Calibri"/>
+              </a:defRPr>
+            </a:pPr>
+            <a:r>
+              <a:t>#2 SARM1 KD (0.692): Highest Cohen's d, bidirectional ✓. Gain-of-function pathology at protein level. Druggable NADase, clinical-stage inhibitors exist.</a:t>
+            </a:r>
+          </a:p>
+        </p:txBody>
+      </p:sp>
+      <p:sp>
+        <p:nvSpPr>
+          <p:cNvPr id="165" name="Shape 208"/>
+          <p:cNvSpPr/>
+          <p:nvPr/>
+        </p:nvSpPr>
+        <p:spPr>
+          <a:xfrm>
+            <a:off x="4750395" y="3987212"/>
+            <a:ext cx="72002" cy="838395"/>
+          </a:xfrm>
+          <a:prstGeom prst="rect">
+            <a:avLst/>
+          </a:prstGeom>
+          <a:solidFill>
+            <a:srgbClr val="2C5F8A"/>
+          </a:solidFill>
+          <a:ln w="12700">
+            <a:solidFill>
+              <a:srgbClr val="2C5F8A"/>
+            </a:solidFill>
+          </a:ln>
+        </p:spPr>
+        <p:txBody>
+          <a:bodyPr lIns="45718" tIns="45718" rIns="45718" bIns="45718"/>
+          <a:lstStyle/>
+          <a:p>
+            <a:pPr>
+              <a:defRPr>
+                <a:latin typeface="+mj-lt"/>
+                <a:ea typeface="+mj-ea"/>
+                <a:cs typeface="+mj-cs"/>
+                <a:sym typeface="Calibri"/>
+              </a:defRPr>
+            </a:pPr>
+          </a:p>
+        </p:txBody>
+      </p:sp>
+      <p:sp>
+        <p:nvSpPr>
+          <p:cNvPr id="166" name="Text 209"/>
+          <p:cNvSpPr txBox="1"/>
+          <p:nvPr/>
+        </p:nvSpPr>
+        <p:spPr>
+          <a:xfrm>
+            <a:off x="4865255" y="4059613"/>
+            <a:ext cx="4062282" cy="718993"/>
+          </a:xfrm>
+          <a:prstGeom prst="rect">
+            <a:avLst/>
+          </a:prstGeom>
+          <a:ln w="12700">
+            <a:miter lim="400000"/>
+          </a:ln>
+          <a:extLst>
+            <a:ext uri="{C572A759-6A51-4108-AA02-DFA0A04FC94B}">
+              <ma14:wrappingTextBoxFlag xmlns:ma14="http://schemas.microsoft.com/office/mac/drawingml/2011/main" val="1"/>
+            </a:ext>
+          </a:extLst>
+        </p:spPr>
+        <p:txBody>
+          <a:bodyPr lIns="22859" tIns="22859" rIns="22859" bIns="22859">
+            <a:spAutoFit/>
+          </a:bodyPr>
+          <a:lstStyle/>
+          <a:p>
+            <a:pPr marL="150394" indent="-150394">
+              <a:buSzPct val="100000"/>
+              <a:buAutoNum type="circleNumDbPlain" startAt="1"/>
+              <a:defRPr b="1" sz="900">
+                <a:solidFill>
+                  <a:srgbClr val="2C5F8A"/>
+                </a:solidFill>
+                <a:latin typeface="+mj-lt"/>
+                <a:ea typeface="+mj-ea"/>
+                <a:cs typeface="+mj-cs"/>
+                <a:sym typeface="Calibri"/>
+              </a:defRPr>
+            </a:pPr>
+            <a:r>
+              <a:t> Fine-tune GeneFormer on VAT1L+ &amp; SCN4B+ cells (disease vs healthy)</a:t>
+            </a:r>
+          </a:p>
+          <a:p>
+            <a:pPr marL="150394" indent="-150394">
+              <a:buSzPct val="100000"/>
+              <a:buAutoNum type="circleNumDbPlain" startAt="1"/>
+              <a:defRPr b="1" sz="900">
+                <a:solidFill>
+                  <a:srgbClr val="2C5F8A"/>
+                </a:solidFill>
+                <a:latin typeface="+mj-lt"/>
+                <a:ea typeface="+mj-ea"/>
+                <a:cs typeface="+mj-cs"/>
+                <a:sym typeface="Calibri"/>
+              </a:defRPr>
+            </a:pPr>
+            <a:r>
+              <a:t> Genome-wide perturbation screen post fine-tuning for unbiased target disc.</a:t>
+            </a:r>
+          </a:p>
+          <a:p>
+            <a:pPr marL="150394" indent="-150394">
+              <a:buSzPct val="100000"/>
+              <a:buAutoNum type="circleNumDbPlain" startAt="1"/>
+              <a:defRPr b="1" sz="900">
+                <a:solidFill>
+                  <a:srgbClr val="2C5F8A"/>
+                </a:solidFill>
+                <a:latin typeface="+mj-lt"/>
+                <a:ea typeface="+mj-ea"/>
+                <a:cs typeface="+mj-cs"/>
+                <a:sym typeface="Calibri"/>
+              </a:defRPr>
+            </a:pPr>
+            <a:r>
+              <a:t> Cross-model replication: run panel through scGPT + TranscriptFormer (both in Helical package)</a:t>
+            </a:r>
+          </a:p>
+          <a:p>
+            <a:pPr marL="150394" indent="-150394">
+              <a:buSzPct val="100000"/>
+              <a:buAutoNum type="circleNumDbPlain" startAt="1"/>
+              <a:defRPr b="1" sz="900">
+                <a:solidFill>
+                  <a:srgbClr val="2C5F8A"/>
+                </a:solidFill>
+                <a:latin typeface="+mj-lt"/>
+                <a:ea typeface="+mj-ea"/>
+                <a:cs typeface="+mj-cs"/>
+                <a:sym typeface="Calibri"/>
+              </a:defRPr>
+            </a:pPr>
+            <a:r>
+              <a:t> </a:t>
+            </a:r>
+            <a:r>
+              <a:rPr i="1"/>
+              <a:t>Experimental: STMN2 ASO + SARM1 inhibitor in ALS iPSC motor neurons.</a:t>
+            </a:r>
+          </a:p>
+        </p:txBody>
+      </p:sp>
+      <p:grpSp>
+        <p:nvGrpSpPr>
+          <p:cNvPr id="169" name="Shape 200"/>
+          <p:cNvGrpSpPr/>
+          <p:nvPr/>
+        </p:nvGrpSpPr>
+        <p:grpSpPr>
+          <a:xfrm>
+            <a:off x="4744838" y="3785709"/>
+            <a:ext cx="4200002" cy="190004"/>
+            <a:chOff x="0" y="0"/>
+            <a:chExt cx="4200001" cy="190002"/>
+          </a:xfrm>
+        </p:grpSpPr>
+        <p:sp>
+          <p:nvSpPr>
+            <p:cNvPr id="167" name="Rectangle"/>
+            <p:cNvSpPr/>
+            <p:nvPr/>
+          </p:nvSpPr>
+          <p:spPr>
+            <a:xfrm>
+              <a:off x="-1" y="-1"/>
+              <a:ext cx="4200002" cy="190003"/>
+            </a:xfrm>
+            <a:prstGeom prst="rect">
+              <a:avLst/>
+            </a:prstGeom>
+            <a:solidFill>
+              <a:srgbClr val="0A2342"/>
+            </a:solidFill>
+            <a:ln w="12700" cap="flat">
+              <a:solidFill>
+                <a:srgbClr val="0A2342"/>
+              </a:solidFill>
+              <a:prstDash val="solid"/>
+              <a:round/>
+            </a:ln>
+            <a:effectLst/>
+          </p:spPr>
+          <p:txBody>
+            <a:bodyPr wrap="square" lIns="45718" tIns="45718" rIns="45718" bIns="45718" numCol="1" anchor="ctr">
+              <a:noAutofit/>
+            </a:bodyPr>
+            <a:lstStyle/>
+            <a:p>
+              <a:pPr algn="ctr">
+                <a:defRPr>
+                  <a:latin typeface="+mj-lt"/>
+                  <a:ea typeface="+mj-ea"/>
+                  <a:cs typeface="+mj-cs"/>
+                  <a:sym typeface="Calibri"/>
+                </a:defRPr>
+              </a:pPr>
+            </a:p>
+          </p:txBody>
+        </p:sp>
+        <p:sp>
+          <p:nvSpPr>
+            <p:cNvPr id="168" name="KEY FINDINGS and NEXT STEPS"/>
+            <p:cNvSpPr txBox="1"/>
+            <p:nvPr/>
+          </p:nvSpPr>
+          <p:spPr>
+            <a:xfrm>
+              <a:off x="74930" y="3605"/>
+              <a:ext cx="4050141" cy="182789"/>
+            </a:xfrm>
+            <a:prstGeom prst="rect">
+              <a:avLst/>
+            </a:prstGeom>
+            <a:noFill/>
+            <a:ln w="12700" cap="flat">
+              <a:noFill/>
+              <a:miter lim="400000"/>
+            </a:ln>
+            <a:effectLst/>
+            <a:extLst>
+              <a:ext uri="{C572A759-6A51-4108-AA02-DFA0A04FC94B}">
+                <ma14:wrappingTextBoxFlag xmlns:ma14="http://schemas.microsoft.com/office/mac/drawingml/2011/main" val="1"/>
+              </a:ext>
+            </a:extLst>
+          </p:spPr>
+          <p:txBody>
+            <a:bodyPr wrap="square" lIns="22859" tIns="22859" rIns="22859" bIns="22859" numCol="1" anchor="ctr">
+              <a:spAutoFit/>
+            </a:bodyPr>
+            <a:lstStyle>
+              <a:lvl1pPr algn="ctr">
+                <a:defRPr b="1" sz="1000">
+                  <a:solidFill>
+                    <a:srgbClr val="FFFFFF"/>
+                  </a:solidFill>
+                  <a:latin typeface="+mj-lt"/>
+                  <a:ea typeface="+mj-ea"/>
+                  <a:cs typeface="+mj-cs"/>
+                  <a:sym typeface="Calibri"/>
+                </a:defRPr>
+              </a:lvl1pPr>
+            </a:lstStyle>
+            <a:p>
+              <a:pPr/>
+              <a:r>
+                <a:t>NEXT STEPS</a:t>
+              </a:r>
+            </a:p>
+          </p:txBody>
+        </p:sp>
+      </p:grpSp>
+      <p:sp>
+        <p:nvSpPr>
+          <p:cNvPr id="170" name="Shape 207"/>
+          <p:cNvSpPr/>
+          <p:nvPr/>
+        </p:nvSpPr>
+        <p:spPr>
+          <a:xfrm>
+            <a:off x="280670" y="3133314"/>
+            <a:ext cx="4190475" cy="379449"/>
+          </a:xfrm>
+          <a:prstGeom prst="rect">
+            <a:avLst/>
+          </a:prstGeom>
+          <a:gradFill>
+            <a:gsLst>
+              <a:gs pos="0">
+                <a:srgbClr val="6DBC38"/>
+              </a:gs>
+              <a:gs pos="100000">
+                <a:srgbClr val="BAFD9D"/>
+              </a:gs>
+            </a:gsLst>
+            <a:lin ang="16200000"/>
+          </a:gradFill>
+          <a:ln w="12700">
+            <a:miter lim="400000"/>
+          </a:ln>
+        </p:spPr>
+        <p:txBody>
+          <a:bodyPr lIns="45718" tIns="45718" rIns="45718" bIns="45718"/>
+          <a:lstStyle/>
+          <a:p>
+            <a:pPr>
+              <a:defRPr>
+                <a:solidFill>
+                  <a:srgbClr val="FFFFFF"/>
+                </a:solidFill>
+              </a:defRPr>
+            </a:pPr>
+          </a:p>
+        </p:txBody>
+      </p:sp>
+      <p:sp>
+        <p:nvSpPr>
+          <p:cNvPr id="171" name="Shape 208"/>
+          <p:cNvSpPr/>
+          <p:nvPr/>
+        </p:nvSpPr>
+        <p:spPr>
+          <a:xfrm>
+            <a:off x="280670" y="3133314"/>
+            <a:ext cx="72002" cy="366749"/>
+          </a:xfrm>
+          <a:prstGeom prst="rect">
+            <a:avLst/>
+          </a:prstGeom>
+          <a:solidFill>
+            <a:srgbClr val="1C7A4A"/>
+          </a:solidFill>
+          <a:ln w="12700">
+            <a:solidFill>
+              <a:srgbClr val="0B7A4A"/>
+            </a:solidFill>
+          </a:ln>
+        </p:spPr>
+        <p:txBody>
+          <a:bodyPr lIns="45718" tIns="45718" rIns="45718" bIns="45718"/>
+          <a:lstStyle/>
+          <a:p>
+            <a:pPr>
+              <a:defRPr>
+                <a:latin typeface="+mj-lt"/>
+                <a:ea typeface="+mj-ea"/>
+                <a:cs typeface="+mj-cs"/>
+                <a:sym typeface="Calibri"/>
+              </a:defRPr>
+            </a:pPr>
+          </a:p>
+        </p:txBody>
+      </p:sp>
+      <p:sp>
+        <p:nvSpPr>
+          <p:cNvPr id="172" name="Text 209"/>
+          <p:cNvSpPr txBox="1"/>
+          <p:nvPr/>
+        </p:nvSpPr>
+        <p:spPr>
+          <a:xfrm>
+            <a:off x="395529" y="3160162"/>
+            <a:ext cx="4062283" cy="325754"/>
+          </a:xfrm>
+          <a:prstGeom prst="rect">
+            <a:avLst/>
+          </a:prstGeom>
+          <a:ln w="12700">
+            <a:miter lim="400000"/>
+          </a:ln>
+          <a:extLst>
+            <a:ext uri="{C572A759-6A51-4108-AA02-DFA0A04FC94B}">
+              <ma14:wrappingTextBoxFlag xmlns:ma14="http://schemas.microsoft.com/office/mac/drawingml/2011/main" val="1"/>
+            </a:ext>
+          </a:extLst>
+        </p:spPr>
+        <p:txBody>
+          <a:bodyPr lIns="22859" tIns="22859" rIns="22859" bIns="22859">
+            <a:spAutoFit/>
+          </a:bodyPr>
+          <a:lstStyle/>
+          <a:p>
+            <a:pPr>
+              <a:defRPr sz="900">
+                <a:solidFill>
+                  <a:srgbClr val="034E21"/>
+                </a:solidFill>
+                <a:latin typeface="+mj-lt"/>
+                <a:ea typeface="+mj-ea"/>
+                <a:cs typeface="+mj-cs"/>
+                <a:sym typeface="Calibri"/>
+              </a:defRPr>
+            </a:pPr>
+            <a:r>
+              <a:t>Tier 4: Ambiguous: </a:t>
+            </a:r>
+            <a:r>
+              <a:rPr i="1" sz="700"/>
+              <a:t>UNC13A, NEK1, POU3F1. inconsistent across populations.</a:t>
+            </a:r>
+          </a:p>
+          <a:p>
+            <a:pPr>
+              <a:lnSpc>
+                <a:spcPts val="1100"/>
+              </a:lnSpc>
+              <a:defRPr sz="800">
+                <a:solidFill>
+                  <a:srgbClr val="034E21"/>
+                </a:solidFill>
+                <a:latin typeface="+mj-lt"/>
+                <a:ea typeface="+mj-ea"/>
+                <a:cs typeface="+mj-cs"/>
+                <a:sym typeface="Calibri"/>
+              </a:defRPr>
+            </a:pPr>
+            <a:r>
+              <a:rPr sz="900"/>
+              <a:t>Control</a:t>
+            </a:r>
+            <a:r>
+              <a:t>: ACTB: near-zero shift, validates framework specificity.</a:t>
+            </a:r>
+          </a:p>
+        </p:txBody>
+      </p:sp>
+      <p:sp>
+        <p:nvSpPr>
+          <p:cNvPr id="173" name="Shape 201"/>
+          <p:cNvSpPr/>
+          <p:nvPr/>
+        </p:nvSpPr>
+        <p:spPr>
+          <a:xfrm>
+            <a:off x="275113" y="3781097"/>
+            <a:ext cx="4200002" cy="1088573"/>
+          </a:xfrm>
+          <a:prstGeom prst="rect">
+            <a:avLst/>
+          </a:prstGeom>
+          <a:gradFill>
+            <a:gsLst>
+              <a:gs pos="0">
+                <a:srgbClr val="499CE7"/>
+              </a:gs>
+              <a:gs pos="100000">
+                <a:schemeClr val="accent5">
+                  <a:hueOff val="329330"/>
+                  <a:satOff val="40776"/>
+                  <a:lumOff val="24655"/>
+                </a:schemeClr>
+              </a:gs>
+            </a:gsLst>
+            <a:lin ang="16200000"/>
+          </a:gradFill>
+          <a:ln>
+            <a:solidFill>
+              <a:schemeClr val="accent1">
+                <a:satOff val="-3547"/>
+                <a:lumOff val="-10352"/>
+              </a:schemeClr>
+            </a:solidFill>
+          </a:ln>
+        </p:spPr>
+        <p:txBody>
+          <a:bodyPr lIns="45718" tIns="45718" rIns="45718" bIns="45718"/>
+          <a:lstStyle/>
+          <a:p>
+            <a:pPr>
+              <a:defRPr>
+                <a:solidFill>
+                  <a:srgbClr val="FFFFFF"/>
+                </a:solidFill>
+              </a:defRPr>
+            </a:pPr>
+          </a:p>
+        </p:txBody>
+      </p:sp>
+      <p:sp>
+        <p:nvSpPr>
+          <p:cNvPr id="174" name="Shape 202"/>
+          <p:cNvSpPr/>
+          <p:nvPr/>
+        </p:nvSpPr>
+        <p:spPr>
+          <a:xfrm>
+            <a:off x="275113" y="3781097"/>
+            <a:ext cx="72002" cy="1088573"/>
+          </a:xfrm>
+          <a:prstGeom prst="rect">
+            <a:avLst/>
+          </a:prstGeom>
+          <a:solidFill>
+            <a:srgbClr val="1612A3"/>
+          </a:solidFill>
+          <a:ln w="12700">
+            <a:solidFill>
+              <a:srgbClr val="0E7C7B"/>
+            </a:solidFill>
+          </a:ln>
+        </p:spPr>
+        <p:txBody>
+          <a:bodyPr lIns="45718" tIns="45718" rIns="45718" bIns="45718"/>
+          <a:lstStyle/>
+          <a:p>
+            <a:pPr>
+              <a:defRPr>
+                <a:latin typeface="+mj-lt"/>
+                <a:ea typeface="+mj-ea"/>
+                <a:cs typeface="+mj-cs"/>
+                <a:sym typeface="Calibri"/>
+              </a:defRPr>
+            </a:pPr>
+          </a:p>
+        </p:txBody>
+      </p:sp>
+      <p:sp>
+        <p:nvSpPr>
+          <p:cNvPr id="175" name="Text 203"/>
+          <p:cNvSpPr txBox="1"/>
+          <p:nvPr/>
+        </p:nvSpPr>
+        <p:spPr>
+          <a:xfrm>
+            <a:off x="389973" y="3802238"/>
+            <a:ext cx="4062282" cy="924996"/>
+          </a:xfrm>
+          <a:prstGeom prst="rect">
+            <a:avLst/>
+          </a:prstGeom>
+          <a:ln w="12700">
+            <a:miter lim="400000"/>
+          </a:ln>
+          <a:extLst>
+            <a:ext uri="{C572A759-6A51-4108-AA02-DFA0A04FC94B}">
+              <ma14:wrappingTextBoxFlag xmlns:ma14="http://schemas.microsoft.com/office/mac/drawingml/2011/main" val="1"/>
+            </a:ext>
+          </a:extLst>
+        </p:spPr>
+        <p:txBody>
+          <a:bodyPr lIns="22859" tIns="22859" rIns="22859" bIns="22859">
+            <a:spAutoFit/>
+          </a:bodyPr>
+          <a:lstStyle/>
           <a:p>
             <a:pPr>
               <a:defRPr b="1" sz="900">
@@ -7552,120 +8379,14 @@
               </a:defRPr>
             </a:pPr>
             <a:r>
-              <a:t>#1 Priority </a:t>
-            </a:r>
-          </a:p>
-        </p:txBody>
-      </p:sp>
-      <p:sp>
-        <p:nvSpPr>
-          <p:cNvPr id="159" name="Shape 207"/>
-          <p:cNvSpPr/>
-          <p:nvPr/>
-        </p:nvSpPr>
-        <p:spPr>
-          <a:xfrm>
-            <a:off x="279876" y="3209291"/>
-            <a:ext cx="4190476" cy="554073"/>
-          </a:xfrm>
-          <a:prstGeom prst="rect">
-            <a:avLst/>
-          </a:prstGeom>
-          <a:solidFill>
-            <a:srgbClr val="EAF0F8"/>
-          </a:solidFill>
-          <a:ln>
-            <a:solidFill>
-              <a:srgbClr val="BACED9"/>
-            </a:solidFill>
-          </a:ln>
-        </p:spPr>
-        <p:txBody>
-          <a:bodyPr lIns="45718" tIns="45718" rIns="45718" bIns="45718"/>
-          <a:lstStyle/>
+              <a:t>COMBINATORIAL RESULT</a:t>
+            </a:r>
+          </a:p>
           <a:p>
             <a:pPr>
-              <a:defRPr>
-                <a:latin typeface="+mj-lt"/>
-                <a:ea typeface="+mj-ea"/>
-                <a:cs typeface="+mj-cs"/>
-                <a:sym typeface="Calibri"/>
-              </a:defRPr>
-            </a:pPr>
-          </a:p>
-        </p:txBody>
-      </p:sp>
-      <p:sp>
-        <p:nvSpPr>
-          <p:cNvPr id="160" name="Shape 208"/>
-          <p:cNvSpPr/>
-          <p:nvPr/>
-        </p:nvSpPr>
-        <p:spPr>
-          <a:xfrm>
-            <a:off x="279876" y="3209291"/>
-            <a:ext cx="72001" cy="554073"/>
-          </a:xfrm>
-          <a:prstGeom prst="rect">
-            <a:avLst/>
-          </a:prstGeom>
-          <a:solidFill>
-            <a:srgbClr val="2C5F8A"/>
-          </a:solidFill>
-          <a:ln w="12700">
-            <a:solidFill>
-              <a:srgbClr val="2C5F8A"/>
-            </a:solidFill>
-          </a:ln>
-        </p:spPr>
-        <p:txBody>
-          <a:bodyPr lIns="45718" tIns="45718" rIns="45718" bIns="45718"/>
-          <a:lstStyle/>
-          <a:p>
-            <a:pPr>
-              <a:defRPr>
-                <a:latin typeface="+mj-lt"/>
-                <a:ea typeface="+mj-ea"/>
-                <a:cs typeface="+mj-cs"/>
-                <a:sym typeface="Calibri"/>
-              </a:defRPr>
-            </a:pPr>
-          </a:p>
-        </p:txBody>
-      </p:sp>
-      <p:sp>
-        <p:nvSpPr>
-          <p:cNvPr id="161" name="Text 209"/>
-          <p:cNvSpPr txBox="1"/>
-          <p:nvPr/>
-        </p:nvSpPr>
-        <p:spPr>
-          <a:xfrm>
-            <a:off x="394736" y="3230432"/>
-            <a:ext cx="4062281" cy="299893"/>
-          </a:xfrm>
-          <a:prstGeom prst="rect">
-            <a:avLst/>
-          </a:prstGeom>
-          <a:ln w="12700">
-            <a:miter lim="400000"/>
-          </a:ln>
-          <a:extLst>
-            <a:ext uri="{C572A759-6A51-4108-AA02-DFA0A04FC94B}">
-              <ma14:wrappingTextBoxFlag xmlns:ma14="http://schemas.microsoft.com/office/mac/drawingml/2011/main" val="1"/>
-            </a:ext>
-          </a:extLst>
-        </p:spPr>
-        <p:txBody>
-          <a:bodyPr lIns="22859" tIns="22859" rIns="22859" bIns="22859">
-            <a:spAutoFit/>
-          </a:bodyPr>
-          <a:lstStyle/>
-          <a:p>
-            <a:pPr>
-              <a:defRPr b="1" sz="900">
+              <a:defRPr sz="800">
                 <a:solidFill>
-                  <a:srgbClr val="2C5F8A"/>
+                  <a:srgbClr val="4A6070"/>
                 </a:solidFill>
                 <a:latin typeface="+mj-lt"/>
                 <a:ea typeface="+mj-ea"/>
@@ -7674,23 +8395,7 @@
               </a:defRPr>
             </a:pPr>
             <a:r>
-              <a:t>Try restore on the current gene panel</a:t>
-            </a:r>
-          </a:p>
-          <a:p>
-            <a:pPr>
-              <a:defRPr b="1" sz="900">
-                <a:solidFill>
-                  <a:srgbClr val="2C5F8A"/>
-                </a:solidFill>
-                <a:latin typeface="+mj-lt"/>
-                <a:ea typeface="+mj-ea"/>
-                <a:cs typeface="+mj-cs"/>
-                <a:sym typeface="Calibri"/>
-              </a:defRPr>
-            </a:pPr>
-            <a:r>
-              <a:t>Review the gene panel</a:t>
+              <a:t>Four-gene druggable combination: STMN2 + UNC13A + DCTN1 + DYNC1H1 restore (p = 0.009). The cross-pathway synergy between TDP-43 downstream restoration and axonal transport restoration is the actionable therapeutic hypothesis: transport genes contribute nothing alone but produce additive effects when combined with TDP-43 downstream targets. TARDBP knockdown was excluded from therapeutic combinations because TDP-43 is an essential protein — all clinical programmes target downstream consequences, not TDP-43 itself.</a:t>
             </a:r>
           </a:p>
         </p:txBody>

</xml_diff>